<commit_message>
feat(deck,landing): dark theme, Perché slide, QR code, mobile nav fix
Deck (finale.pptx):
- Invert all 10 slides to dark theme matching relax-room site palette
  (page bg 0B0B14, cards 14142E/1A1A2E/23213C, indigo 9A93F5 accents).
- Insert new slide 2 "Perché & Per Chi" at the start of the deck with
  motivation + target audience, reusing existing copy from slides 4 and 6
  (teacher feedback: motivazioni devono arrivare all'inizio).
- Remove wrong link "mini-cozy-room.netlify.app/team/renan" from slide 1.
- Add QR code on final slide linking to https://relax-room.netlify.app/.
- Word-for-word content preserved on every other slide (byte-identical
  <a:t> runs on slides 2-10 of the original deck).

Landing page (docs/style.css):
- Collapse .mobile-menu via max-height when not .active; was always rendered
  at full height inside the fixed navbar, eating ~50% of phone viewport.
- Desktop behavior unchanged.
</commit_message>
<xml_diff>
--- a/finale.pptx
+++ b/finale.pptx
@@ -9,6 +9,7 @@
   </p:notesMasterIdLst>
   <p:sldIdLst>
     <p:sldId id="256" r:id="rId3"/>
+    <p:sldId id="266" r:id="rId17"/>
     <p:sldId id="257" r:id="rId4"/>
     <p:sldId id="258" r:id="rId5"/>
     <p:sldId id="259" r:id="rId6"/>
@@ -1253,7 +1254,7 @@
   <p:cSld name="DEFAULT">
     <p:bg>
       <p:bgRef idx="1001">
-        <a:schemeClr val="bg1"/>
+        <a:srgbClr val="14142E"/>
       </p:bgRef>
     </p:bg>
     <p:spTree>
@@ -1284,7 +1285,7 @@
     <p:bg>
       <p:bgPr shadeToTitle="0">
         <a:solidFill>
-          <a:srgbClr val="000000"/>
+          <a:srgbClr val="0B0B14"/>
         </a:solidFill>
       </p:bgPr>
     </p:bg>
@@ -1317,7 +1318,7 @@
             <a:avLst/>
           </a:prstGeom>
           <a:solidFill>
-            <a:srgbClr val="F4F0FF"/>
+            <a:srgbClr val="0B0B14"/>
           </a:solidFill>
           <a:ln/>
         </p:spPr>
@@ -1337,7 +1338,7 @@
             <a:avLst/>
           </a:prstGeom>
           <a:solidFill>
-            <a:srgbClr val="FBFAFF"/>
+            <a:srgbClr val="14142E"/>
           </a:solidFill>
           <a:ln/>
         </p:spPr>
@@ -1380,7 +1381,7 @@
     <p:bg>
       <p:bgPr shadeToTitle="0">
         <a:solidFill>
-          <a:srgbClr val="000000"/>
+          <a:srgbClr val="0B0B14"/>
         </a:solidFill>
       </p:bgPr>
     </p:bg>
@@ -1413,7 +1414,7 @@
             <a:avLst/>
           </a:prstGeom>
           <a:solidFill>
-            <a:srgbClr val="F4F0FF"/>
+            <a:srgbClr val="0B0B14"/>
           </a:solidFill>
           <a:ln/>
         </p:spPr>
@@ -1433,7 +1434,7 @@
             <a:avLst/>
           </a:prstGeom>
           <a:solidFill>
-            <a:srgbClr val="FBFAFF"/>
+            <a:srgbClr val="14142E"/>
           </a:solidFill>
           <a:ln/>
         </p:spPr>
@@ -1476,7 +1477,7 @@
     <p:bg>
       <p:bgPr shadeToTitle="0">
         <a:solidFill>
-          <a:srgbClr val="000000"/>
+          <a:srgbClr val="0B0B14"/>
         </a:solidFill>
       </p:bgPr>
     </p:bg>
@@ -1509,7 +1510,7 @@
             <a:avLst/>
           </a:prstGeom>
           <a:solidFill>
-            <a:srgbClr val="F4F0FF"/>
+            <a:srgbClr val="0B0B14"/>
           </a:solidFill>
           <a:ln/>
         </p:spPr>
@@ -1529,7 +1530,7 @@
             <a:avLst/>
           </a:prstGeom>
           <a:solidFill>
-            <a:srgbClr val="FBFAFF"/>
+            <a:srgbClr val="14142E"/>
           </a:solidFill>
           <a:ln/>
         </p:spPr>
@@ -1572,7 +1573,7 @@
     <p:bg>
       <p:bgPr shadeToTitle="0">
         <a:solidFill>
-          <a:srgbClr val="000000"/>
+          <a:srgbClr val="0B0B14"/>
         </a:solidFill>
       </p:bgPr>
     </p:bg>
@@ -1605,7 +1606,7 @@
             <a:avLst/>
           </a:prstGeom>
           <a:solidFill>
-            <a:srgbClr val="F4F0FF"/>
+            <a:srgbClr val="0B0B14"/>
           </a:solidFill>
           <a:ln/>
         </p:spPr>
@@ -1625,7 +1626,7 @@
             <a:avLst/>
           </a:prstGeom>
           <a:solidFill>
-            <a:srgbClr val="FBFAFF"/>
+            <a:srgbClr val="14142E"/>
           </a:solidFill>
           <a:ln/>
         </p:spPr>
@@ -1668,7 +1669,7 @@
     <p:bg>
       <p:bgPr shadeToTitle="0">
         <a:solidFill>
-          <a:srgbClr val="000000"/>
+          <a:srgbClr val="0B0B14"/>
         </a:solidFill>
       </p:bgPr>
     </p:bg>
@@ -1701,7 +1702,7 @@
             <a:avLst/>
           </a:prstGeom>
           <a:solidFill>
-            <a:srgbClr val="F4F0FF"/>
+            <a:srgbClr val="0B0B14"/>
           </a:solidFill>
           <a:ln/>
         </p:spPr>
@@ -1721,7 +1722,7 @@
             <a:avLst/>
           </a:prstGeom>
           <a:solidFill>
-            <a:srgbClr val="FBFAFF"/>
+            <a:srgbClr val="14142E"/>
           </a:solidFill>
           <a:ln/>
         </p:spPr>
@@ -1764,7 +1765,7 @@
     <p:bg>
       <p:bgPr shadeToTitle="0">
         <a:solidFill>
-          <a:srgbClr val="000000"/>
+          <a:srgbClr val="0B0B14"/>
         </a:solidFill>
       </p:bgPr>
     </p:bg>
@@ -1797,7 +1798,7 @@
             <a:avLst/>
           </a:prstGeom>
           <a:solidFill>
-            <a:srgbClr val="F4F0FF"/>
+            <a:srgbClr val="0B0B14"/>
           </a:solidFill>
           <a:ln/>
         </p:spPr>
@@ -1817,7 +1818,7 @@
             <a:avLst/>
           </a:prstGeom>
           <a:solidFill>
-            <a:srgbClr val="FBFAFF"/>
+            <a:srgbClr val="14142E"/>
           </a:solidFill>
           <a:ln/>
         </p:spPr>
@@ -1860,7 +1861,7 @@
     <p:bg>
       <p:bgPr shadeToTitle="0">
         <a:solidFill>
-          <a:srgbClr val="000000"/>
+          <a:srgbClr val="0B0B14"/>
         </a:solidFill>
       </p:bgPr>
     </p:bg>
@@ -1893,7 +1894,7 @@
             <a:avLst/>
           </a:prstGeom>
           <a:solidFill>
-            <a:srgbClr val="F4F0FF"/>
+            <a:srgbClr val="0B0B14"/>
           </a:solidFill>
           <a:ln/>
         </p:spPr>
@@ -1913,7 +1914,7 @@
             <a:avLst/>
           </a:prstGeom>
           <a:solidFill>
-            <a:srgbClr val="FBFAFF"/>
+            <a:srgbClr val="14142E"/>
           </a:solidFill>
           <a:ln/>
         </p:spPr>
@@ -2304,7 +2305,7 @@
             <a:r>
               <a:rPr lang="en-US" sz="5200" b="1">
                 <a:solidFill>
-                  <a:srgbClr val="403CCF"/>
+                  <a:srgbClr val="9A93F5"/>
                 </a:solidFill>
                 <a:latin typeface="Libre Baskerville"/>
                 <a:ea typeface="Libre Baskerville"/>
@@ -2333,7 +2334,7 @@
             </a:avLst>
           </a:prstGeom>
           <a:solidFill>
-            <a:srgbClr val="D7D6F5"/>
+            <a:srgbClr val="23213C"/>
           </a:solidFill>
           <a:ln/>
         </p:spPr>
@@ -2397,7 +2398,7 @@
             <a:r>
               <a:rPr lang="en-US" sz="1500">
                 <a:solidFill>
-                  <a:srgbClr val="49495A"/>
+                  <a:srgbClr val="C4B8F5"/>
                 </a:solidFill>
                 <a:latin typeface="Open Sans"/>
                 <a:ea typeface="Open Sans"/>
@@ -2440,7 +2441,7 @@
             <a:r>
               <a:rPr lang="en-US" sz="2200">
                 <a:solidFill>
-                  <a:srgbClr val="5955EB"/>
+                  <a:srgbClr val="ADA8F9"/>
                 </a:solidFill>
                 <a:latin typeface="Libre Baskerville"/>
                 <a:ea typeface="Libre Baskerville"/>
@@ -2451,7 +2452,7 @@
             <a:r>
               <a:rPr lang="en-US" sz="2200">
                 <a:solidFill>
-                  <a:srgbClr val="403CCF"/>
+                  <a:srgbClr val="9A93F5"/>
                 </a:solidFill>
                 <a:latin typeface="Libre Baskerville"/>
                 <a:ea typeface="Libre Baskerville"/>
@@ -2494,7 +2495,7 @@
             <a:r>
               <a:rPr lang="en-US" sz="1750">
                 <a:solidFill>
-                  <a:srgbClr val="49495A"/>
+                  <a:srgbClr val="C4B8F5"/>
                 </a:solidFill>
                 <a:latin typeface="Open Sans"/>
                 <a:ea typeface="Open Sans"/>
@@ -2505,7 +2506,7 @@
             <a:r>
               <a:rPr lang="en-US" sz="1750" b="1">
                 <a:solidFill>
-                  <a:srgbClr val="49495A"/>
+                  <a:srgbClr val="C4B8F5"/>
                 </a:solidFill>
                 <a:latin typeface="Open Sans"/>
                 <a:ea typeface="Open Sans"/>
@@ -2516,7 +2517,7 @@
             <a:r>
               <a:rPr lang="en-US" sz="1750">
                 <a:solidFill>
-                  <a:srgbClr val="49495A"/>
+                  <a:srgbClr val="C4B8F5"/>
                 </a:solidFill>
                 <a:latin typeface="Open Sans"/>
                 <a:ea typeface="Open Sans"/>
@@ -2527,7 +2528,7 @@
             <a:r>
               <a:rPr lang="en-US" sz="1750" b="1">
                 <a:solidFill>
-                  <a:srgbClr val="49495A"/>
+                  <a:srgbClr val="C4B8F5"/>
                 </a:solidFill>
                 <a:latin typeface="Open Sans"/>
                 <a:ea typeface="Open Sans"/>
@@ -2538,7 +2539,7 @@
             <a:r>
               <a:rPr lang="en-US" sz="1750">
                 <a:solidFill>
-                  <a:srgbClr val="49495A"/>
+                  <a:srgbClr val="C4B8F5"/>
                 </a:solidFill>
                 <a:latin typeface="Open Sans"/>
                 <a:ea typeface="Open Sans"/>
@@ -2549,7 +2550,7 @@
             <a:r>
               <a:rPr lang="en-US" sz="1750" b="1">
                 <a:solidFill>
-                  <a:srgbClr val="49495A"/>
+                  <a:srgbClr val="C4B8F5"/>
                 </a:solidFill>
                 <a:latin typeface="Open Sans"/>
                 <a:ea typeface="Open Sans"/>
@@ -2558,39 +2559,6 @@
               <a:t>Cristian Marino</a:t>
             </a:r>
             <a:endParaRPr lang="en-US" sz="1750"/>
-          </a:p>
-          <a:p>
-            <a:pPr marL="0" indent="0" algn="l">
-              <a:lnSpc>
-                <a:spcPts val="2850"/>
-              </a:lnSpc>
-              <a:buNone/>
-              <a:defRPr/>
-            </a:pPr>
-            <a:r>
-              <a:rPr lang="en-US" sz="1500">
-                <a:solidFill>
-                  <a:srgbClr val="49495A"/>
-                </a:solidFill>
-                <a:latin typeface="Open Sans"/>
-                <a:ea typeface="Open Sans"/>
-                <a:cs typeface="Open Sans"/>
-              </a:rPr>
-              <a:t>🔗 </a:t>
-            </a:r>
-            <a:r>
-              <a:rPr lang="en-US" sz="1500" u="sng">
-                <a:solidFill>
-                  <a:srgbClr val="4F46E5"/>
-                </a:solidFill>
-                <a:latin typeface="Open Sans"/>
-                <a:ea typeface="Open Sans"/>
-                <a:cs typeface="Open Sans"/>
-                <a:hlinkClick r:id="rId6" tooltip=""/>
-              </a:rPr>
-              <a:t>mini-cozy-room.netlify.app</a:t>
-            </a:r>
-            <a:endParaRPr lang="en-US" sz="1500"/>
           </a:p>
         </p:txBody>
       </p:sp>
@@ -2609,7 +2577,7 @@
             <a:avLst/>
           </a:prstGeom>
           <a:solidFill>
-            <a:schemeClr val="bg1"/>
+            <a:srgbClr val="14142E"/>
           </a:solidFill>
           <a:ln w="12700" cap="flat" cmpd="sng" algn="ctr">
             <a:noFill/>
@@ -2714,7 +2682,7 @@
             <a:r>
               <a:rPr lang="en-US" sz="5000" b="1" u="sng">
                 <a:solidFill>
-                  <a:srgbClr val="403CCF"/>
+                  <a:srgbClr val="9A93F5"/>
                 </a:solidFill>
                 <a:latin typeface="Libre Baskerville"/>
                 <a:ea typeface="Libre Baskerville"/>
@@ -2775,11 +2743,11 @@
             </a:avLst>
           </a:prstGeom>
           <a:solidFill>
-            <a:srgbClr val="FBFAFF"/>
+            <a:srgbClr val="14142E"/>
           </a:solidFill>
           <a:ln w="22860">
             <a:solidFill>
-              <a:srgbClr val="D0CED9"/>
+              <a:srgbClr val="1A1A2E"/>
             </a:solidFill>
             <a:prstDash val="solid"/>
           </a:ln>
@@ -2860,7 +2828,7 @@
             <a:r>
               <a:rPr lang="en-US" sz="2200">
                 <a:solidFill>
-                  <a:srgbClr val="49495A"/>
+                  <a:srgbClr val="C4B8F5"/>
                 </a:solidFill>
                 <a:latin typeface="FreeSerif"/>
                 <a:ea typeface="FreeSerif"/>
@@ -2906,7 +2874,7 @@
             <a:r>
               <a:rPr lang="en-US" sz="1400">
                 <a:solidFill>
-                  <a:srgbClr val="49495A"/>
+                  <a:srgbClr val="C4B8F5"/>
                 </a:solidFill>
                 <a:latin typeface="Open Sans"/>
                 <a:ea typeface="Open Sans"/>
@@ -2935,11 +2903,11 @@
             </a:avLst>
           </a:prstGeom>
           <a:solidFill>
-            <a:srgbClr val="FBFAFF"/>
+            <a:srgbClr val="14142E"/>
           </a:solidFill>
           <a:ln w="22860">
             <a:solidFill>
-              <a:srgbClr val="D0CED9"/>
+              <a:srgbClr val="1A1A2E"/>
             </a:solidFill>
             <a:prstDash val="solid"/>
           </a:ln>
@@ -3020,7 +2988,7 @@
             <a:r>
               <a:rPr lang="en-US" sz="2200">
                 <a:solidFill>
-                  <a:srgbClr val="49495A"/>
+                  <a:srgbClr val="C4B8F5"/>
                 </a:solidFill>
                 <a:latin typeface="FreeSerif"/>
                 <a:ea typeface="FreeSerif"/>
@@ -3066,7 +3034,7 @@
             <a:r>
               <a:rPr lang="en-US" sz="1400">
                 <a:solidFill>
-                  <a:srgbClr val="49495A"/>
+                  <a:srgbClr val="C4B8F5"/>
                 </a:solidFill>
                 <a:latin typeface="Open Sans"/>
                 <a:ea typeface="Open Sans"/>
@@ -3095,11 +3063,11 @@
             </a:avLst>
           </a:prstGeom>
           <a:solidFill>
-            <a:srgbClr val="FBFAFF"/>
+            <a:srgbClr val="14142E"/>
           </a:solidFill>
           <a:ln w="22860">
             <a:solidFill>
-              <a:srgbClr val="D0CED9"/>
+              <a:srgbClr val="1A1A2E"/>
             </a:solidFill>
             <a:prstDash val="solid"/>
           </a:ln>
@@ -3180,7 +3148,7 @@
             <a:r>
               <a:rPr lang="en-US" sz="2200">
                 <a:solidFill>
-                  <a:srgbClr val="49495A"/>
+                  <a:srgbClr val="C4B8F5"/>
                 </a:solidFill>
                 <a:latin typeface="FreeSerif"/>
                 <a:ea typeface="FreeSerif"/>
@@ -3226,7 +3194,7 @@
             <a:r>
               <a:rPr lang="en-US" sz="1400">
                 <a:solidFill>
-                  <a:srgbClr val="49495A"/>
+                  <a:srgbClr val="C4B8F5"/>
                 </a:solidFill>
                 <a:latin typeface="Open Sans"/>
                 <a:ea typeface="Open Sans"/>
@@ -3269,7 +3237,7 @@
             <a:r>
               <a:rPr lang="en-US" sz="2000" i="1">
                 <a:solidFill>
-                  <a:srgbClr val="49495A"/>
+                  <a:srgbClr val="C4B8F5"/>
                 </a:solidFill>
                 <a:latin typeface="Open Sans"/>
                 <a:ea typeface="Open Sans"/>
@@ -3280,7 +3248,7 @@
             <a:r>
               <a:rPr lang="en-US" sz="2000" b="1">
                 <a:solidFill>
-                  <a:srgbClr val="49495A"/>
+                  <a:srgbClr val="C4B8F5"/>
                 </a:solidFill>
                 <a:latin typeface="Open Sans"/>
                 <a:ea typeface="Open Sans"/>
@@ -3307,7 +3275,7 @@
             <a:avLst/>
           </a:prstGeom>
           <a:solidFill>
-            <a:srgbClr val="403CCF"/>
+            <a:srgbClr val="5A52DC"/>
           </a:solidFill>
           <a:ln/>
         </p:spPr>
@@ -3343,7 +3311,7 @@
             <a:r>
               <a:rPr lang="en-US" sz="4300">
                 <a:solidFill>
-                  <a:srgbClr val="49495A"/>
+                  <a:srgbClr val="C4B8F5"/>
                 </a:solidFill>
                 <a:latin typeface="Libre Baskerville"/>
                 <a:ea typeface="Libre Baskerville"/>
@@ -3386,7 +3354,7 @@
             <a:r>
               <a:rPr lang="en-US" sz="1900">
                 <a:solidFill>
-                  <a:srgbClr val="49495A"/>
+                  <a:srgbClr val="C4B8F5"/>
                 </a:solidFill>
                 <a:latin typeface="Libre Baskerville"/>
                 <a:ea typeface="Libre Baskerville"/>
@@ -3429,7 +3397,7 @@
             <a:r>
               <a:rPr lang="en-US" sz="1550">
                 <a:solidFill>
-                  <a:srgbClr val="49495A"/>
+                  <a:srgbClr val="C4B8F5"/>
                 </a:solidFill>
                 <a:latin typeface="Open Sans"/>
                 <a:ea typeface="Open Sans"/>
@@ -3472,7 +3440,7 @@
             <a:r>
               <a:rPr lang="en-US" sz="4300">
                 <a:solidFill>
-                  <a:srgbClr val="49495A"/>
+                  <a:srgbClr val="C4B8F5"/>
                 </a:solidFill>
                 <a:latin typeface="Libre Baskerville"/>
                 <a:ea typeface="Libre Baskerville"/>
@@ -3515,7 +3483,7 @@
             <a:r>
               <a:rPr lang="en-US" sz="1900">
                 <a:solidFill>
-                  <a:srgbClr val="49495A"/>
+                  <a:srgbClr val="C4B8F5"/>
                 </a:solidFill>
                 <a:latin typeface="Libre Baskerville"/>
                 <a:ea typeface="Libre Baskerville"/>
@@ -3558,7 +3526,7 @@
             <a:r>
               <a:rPr lang="en-US" sz="1550">
                 <a:solidFill>
-                  <a:srgbClr val="49495A"/>
+                  <a:srgbClr val="C4B8F5"/>
                 </a:solidFill>
                 <a:latin typeface="Open Sans"/>
                 <a:ea typeface="Open Sans"/>
@@ -3601,7 +3569,7 @@
             <a:r>
               <a:rPr lang="en-US" sz="4300">
                 <a:solidFill>
-                  <a:srgbClr val="49495A"/>
+                  <a:srgbClr val="C4B8F5"/>
                 </a:solidFill>
                 <a:latin typeface="Libre Baskerville"/>
                 <a:ea typeface="Libre Baskerville"/>
@@ -3644,7 +3612,7 @@
             <a:r>
               <a:rPr lang="en-US" sz="1900">
                 <a:solidFill>
-                  <a:srgbClr val="49495A"/>
+                  <a:srgbClr val="C4B8F5"/>
                 </a:solidFill>
                 <a:latin typeface="Libre Baskerville"/>
                 <a:ea typeface="Libre Baskerville"/>
@@ -3687,7 +3655,7 @@
             <a:r>
               <a:rPr lang="en-US" sz="1550">
                 <a:solidFill>
-                  <a:srgbClr val="49495A"/>
+                  <a:srgbClr val="C4B8F5"/>
                 </a:solidFill>
                 <a:latin typeface="Open Sans"/>
                 <a:ea typeface="Open Sans"/>
@@ -3730,7 +3698,7 @@
             <a:r>
               <a:rPr lang="en-US" sz="4300">
                 <a:solidFill>
-                  <a:srgbClr val="49495A"/>
+                  <a:srgbClr val="C4B8F5"/>
                 </a:solidFill>
                 <a:latin typeface="Libre Baskerville"/>
                 <a:ea typeface="Libre Baskerville"/>
@@ -3773,7 +3741,7 @@
             <a:r>
               <a:rPr lang="en-US" sz="1900">
                 <a:solidFill>
-                  <a:srgbClr val="49495A"/>
+                  <a:srgbClr val="C4B8F5"/>
                 </a:solidFill>
                 <a:latin typeface="Libre Baskerville"/>
                 <a:ea typeface="Libre Baskerville"/>
@@ -3816,7 +3784,7 @@
             <a:r>
               <a:rPr lang="en-US" sz="1550">
                 <a:solidFill>
-                  <a:srgbClr val="49495A"/>
+                  <a:srgbClr val="C4B8F5"/>
                 </a:solidFill>
                 <a:latin typeface="Open Sans"/>
                 <a:ea typeface="Open Sans"/>
@@ -3859,7 +3827,7 @@
             <a:r>
               <a:rPr lang="en-US" sz="1400" i="1">
                 <a:solidFill>
-                  <a:srgbClr val="49495A"/>
+                  <a:srgbClr val="C4B8F5"/>
                 </a:solidFill>
                 <a:latin typeface="Open Sans"/>
                 <a:ea typeface="Open Sans"/>
@@ -3886,7 +3854,7 @@
             <a:avLst/>
           </a:prstGeom>
           <a:solidFill>
-            <a:schemeClr val="bg1"/>
+            <a:srgbClr val="14142E"/>
           </a:solidFill>
           <a:ln w="12700" cap="flat" cmpd="sng" algn="ctr">
             <a:noFill/>
@@ -3927,6 +3895,32 @@
           </a:p>
         </p:txBody>
       </p:sp>
+      <p:pic>
+        <p:nvPicPr>
+          <p:cNvPr id="4242000001" name="QR Code Relax Room">
+            <a:hlinkClick xmlns:r="http://schemas.openxmlformats.org/officeDocument/2006/relationships" r:id="rId6" tooltip=""/>
+          </p:cNvPr>
+          <p:cNvPicPr>
+            <a:picLocks noChangeAspect="1"/>
+          </p:cNvPicPr>
+          <p:nvPr/>
+        </p:nvPicPr>
+        <p:blipFill rotWithShape="1">
+          <a:blip xmlns:r="http://schemas.openxmlformats.org/officeDocument/2006/relationships" r:embed="rId5"/>
+          <a:stretch>
+            <a:fillRect/>
+          </a:stretch>
+        </p:blipFill>
+        <p:spPr bwMode="auto">
+          <a:xfrm>
+            <a:off x="6515200" y="4550000"/>
+            <a:ext cx="1600000" cy="1600000"/>
+          </a:xfrm>
+          <a:prstGeom prst="rect">
+            <a:avLst/>
+          </a:prstGeom>
+        </p:spPr>
+      </p:pic>
     </p:spTree>
   </p:cSld>
   <p:clrMapOvr>
@@ -3940,6 +3934,371 @@
       <p:transition advClick="1"/>
     </mc:Fallback>
   </mc:AlternateContent>
+</p:sld>
+</file>
+
+<file path=ppt/slides/slide11.xml><?xml version="1.0" encoding="utf-8"?>
+<p:sld xmlns:a="http://schemas.openxmlformats.org/drawingml/2006/main" xmlns:r="http://schemas.openxmlformats.org/officeDocument/2006/relationships" xmlns:p="http://schemas.openxmlformats.org/presentationml/2006/main" xmlns:mc="http://schemas.openxmlformats.org/markup-compatibility/2006" showMasterPhAnim="0" showMasterSp="1" show="1">
+  <p:cSld name="Perché e Per Chi">
+    <p:spTree>
+      <p:nvGrpSpPr>
+        <p:cNvPr id="1" name=""/>
+        <p:cNvGrpSpPr/>
+        <p:nvPr/>
+      </p:nvGrpSpPr>
+      <p:grpSpPr bwMode="auto">
+        <a:xfrm>
+          <a:off x="0" y="0"/>
+          <a:ext cx="0" cy="0"/>
+          <a:chOff x="0" y="0"/>
+          <a:chExt cx="0" cy="0"/>
+        </a:xfrm>
+      </p:grpSpPr>
+      <p:sp>
+        <p:nvSpPr>
+          <p:cNvPr id="1001" name="Title"/>
+          <p:cNvSpPr/>
+          <p:nvPr/>
+        </p:nvSpPr>
+        <p:spPr bwMode="auto">
+          <a:xfrm>
+            <a:off x="731520" y="457200"/>
+            <a:ext cx="13167360" cy="822960"/>
+          </a:xfrm>
+          <a:prstGeom prst="rect">
+            <a:avLst/>
+          </a:prstGeom>
+          <a:noFill/>
+          <a:ln/>
+        </p:spPr>
+        <p:txBody>
+          <a:bodyPr wrap="square" lIns="0" tIns="0" rIns="0" bIns="0" rtlCol="0" anchor="ctr"/>
+          <a:lstStyle/>
+          <a:p>
+            <a:pPr marL="0" indent="0" algn="l">
+              <a:buNone/>
+              <a:defRPr/>
+            </a:pPr>
+            <a:r>
+              <a:rPr lang="it-IT" sz="4200" b="1">
+                <a:solidFill>
+                  <a:srgbClr val="9A93F5"/>
+                </a:solidFill>
+                <a:latin typeface="Open Sans"/>
+                <a:ea typeface="Open Sans"/>
+                <a:cs typeface="Open Sans"/>
+              </a:rPr>
+              <a:t>Perché &amp; Per Chi</a:t>
+            </a:r>
+            <a:endParaRPr lang="it-IT"/>
+          </a:p>
+        </p:txBody>
+      </p:sp>
+      <p:sp>
+        <p:nvSpPr>
+          <p:cNvPr id="1100" name="Perché Card"/>
+          <p:cNvSpPr/>
+          <p:nvPr/>
+        </p:nvSpPr>
+        <p:spPr bwMode="auto">
+          <a:xfrm>
+            <a:off x="731520" y="1700000"/>
+            <a:ext cx="6483680" cy="5500000"/>
+          </a:xfrm>
+          <a:prstGeom prst="roundRect">
+            <a:avLst>
+              <a:gd name="adj" fmla="val 6000"/>
+            </a:avLst>
+          </a:prstGeom>
+          <a:solidFill>
+            <a:srgbClr val="23213C"/>
+          </a:solidFill>
+          <a:ln w="9525">
+            <a:solidFill>
+              <a:srgbClr val="33325A"/>
+            </a:solidFill>
+          </a:ln>
+        </p:spPr>
+      </p:sp>
+      <p:sp>
+        <p:nvSpPr>
+          <p:cNvPr id="1101" name="Perché Card Stripe"/>
+          <p:cNvSpPr/>
+          <p:nvPr/>
+        </p:nvSpPr>
+        <p:spPr bwMode="auto">
+          <a:xfrm>
+            <a:off x="911520" y="2060000"/>
+            <a:ext cx="60000" cy="4780000"/>
+          </a:xfrm>
+          <a:prstGeom prst="rect">
+            <a:avLst/>
+          </a:prstGeom>
+          <a:solidFill>
+            <a:srgbClr val="9A93F5"/>
+          </a:solidFill>
+          <a:ln>
+            <a:noFill/>
+          </a:ln>
+        </p:spPr>
+      </p:sp>
+      <p:sp>
+        <p:nvSpPr>
+          <p:cNvPr id="1110" name="Perché Label"/>
+          <p:cNvSpPr/>
+          <p:nvPr/>
+        </p:nvSpPr>
+        <p:spPr bwMode="auto">
+          <a:xfrm>
+            <a:off x="1161520" y="2120000"/>
+            <a:ext cx="4000000" cy="450000"/>
+          </a:xfrm>
+          <a:prstGeom prst="rect">
+            <a:avLst/>
+          </a:prstGeom>
+          <a:noFill/>
+          <a:ln/>
+        </p:spPr>
+        <p:txBody>
+          <a:bodyPr wrap="square" lIns="0" tIns="0" rIns="0" bIns="0" rtlCol="0" anchor="t"/>
+          <a:lstStyle/>
+          <a:p>
+            <a:pPr marL="0" indent="0" algn="l">
+              <a:buNone/>
+              <a:defRPr/>
+            </a:pPr>
+            <a:r>
+              <a:rPr lang="it-IT" sz="1600" b="1" spc="300">
+                <a:solidFill>
+                  <a:srgbClr val="A7A0F8"/>
+                </a:solidFill>
+                <a:latin typeface="Open Sans"/>
+                <a:ea typeface="Open Sans"/>
+                <a:cs typeface="Open Sans"/>
+              </a:rPr>
+              <a:t>PERCHÉ</a:t>
+            </a:r>
+            <a:endParaRPr lang="it-IT"/>
+          </a:p>
+        </p:txBody>
+      </p:sp>
+      <p:sp>
+        <p:nvSpPr>
+          <p:cNvPr id="1111" name="Perché Quote"/>
+          <p:cNvSpPr/>
+          <p:nvPr/>
+        </p:nvSpPr>
+        <p:spPr bwMode="auto">
+          <a:xfrm>
+            <a:off x="1161520" y="2800000"/>
+            <a:ext cx="5623680" cy="4000000"/>
+          </a:xfrm>
+          <a:prstGeom prst="rect">
+            <a:avLst/>
+          </a:prstGeom>
+          <a:noFill/>
+          <a:ln/>
+        </p:spPr>
+        <p:txBody>
+          <a:bodyPr wrap="square" lIns="0" tIns="0" rIns="0" bIns="0" rtlCol="0" anchor="t"/>
+          <a:lstStyle/>
+          <a:p>
+            <a:pPr marL="0" indent="0" algn="l">
+              <a:buNone/>
+              <a:defRPr/>
+            </a:pPr>
+            <a:r>
+              <a:rPr lang="it-IT" sz="4400" b="1">
+                <a:solidFill>
+                  <a:srgbClr val="9A93F5"/>
+                </a:solidFill>
+                <a:latin typeface="Libre Baskerville"/>
+                <a:ea typeface="Libre Baskerville"/>
+                <a:cs typeface="Libre Baskerville"/>
+              </a:rPr>
+              <a:t>« </a:t>
+            </a:r>
+            <a:r>
+              <a:rPr lang="it-IT" sz="2800" i="1">
+                <a:solidFill>
+                  <a:srgbClr val="F2EEFF"/>
+                </a:solidFill>
+                <a:latin typeface="Libre Baskerville"/>
+                <a:ea typeface="Libre Baskerville"/>
+                <a:cs typeface="Libre Baskerville"/>
+              </a:rPr>
+              <a:t>In un mondo che corre, abbiamo costruito un angolo dove fermarsi.</a:t>
+            </a:r>
+            <a:r>
+              <a:rPr lang="it-IT" sz="4400" b="1">
+                <a:solidFill>
+                  <a:srgbClr val="9A93F5"/>
+                </a:solidFill>
+                <a:latin typeface="Libre Baskerville"/>
+                <a:ea typeface="Libre Baskerville"/>
+                <a:cs typeface="Libre Baskerville"/>
+              </a:rPr>
+              <a:t> »</a:t>
+            </a:r>
+            <a:endParaRPr lang="it-IT"/>
+          </a:p>
+        </p:txBody>
+      </p:sp>
+      <p:sp>
+        <p:nvSpPr>
+          <p:cNvPr id="1200" name="Per Chi Card"/>
+          <p:cNvSpPr/>
+          <p:nvPr/>
+        </p:nvSpPr>
+        <p:spPr bwMode="auto">
+          <a:xfrm>
+            <a:off x="7415200" y="1700000"/>
+            <a:ext cx="6483680" cy="5500000"/>
+          </a:xfrm>
+          <a:prstGeom prst="roundRect">
+            <a:avLst>
+              <a:gd name="adj" fmla="val 6000"/>
+            </a:avLst>
+          </a:prstGeom>
+          <a:solidFill>
+            <a:srgbClr val="23213C"/>
+          </a:solidFill>
+          <a:ln w="9525">
+            <a:solidFill>
+              <a:srgbClr val="33325A"/>
+            </a:solidFill>
+          </a:ln>
+        </p:spPr>
+      </p:sp>
+      <p:sp>
+        <p:nvSpPr>
+          <p:cNvPr id="1201" name="Per Chi Card Stripe"/>
+          <p:cNvSpPr/>
+          <p:nvPr/>
+        </p:nvSpPr>
+        <p:spPr bwMode="auto">
+          <a:xfrm>
+            <a:off x="7595200" y="2060000"/>
+            <a:ext cx="60000" cy="4780000"/>
+          </a:xfrm>
+          <a:prstGeom prst="rect">
+            <a:avLst/>
+          </a:prstGeom>
+          <a:solidFill>
+            <a:srgbClr val="FF6B6B"/>
+          </a:solidFill>
+          <a:ln>
+            <a:noFill/>
+          </a:ln>
+        </p:spPr>
+      </p:sp>
+      <p:sp>
+        <p:nvSpPr>
+          <p:cNvPr id="1210" name="Per Chi Label"/>
+          <p:cNvSpPr/>
+          <p:nvPr/>
+        </p:nvSpPr>
+        <p:spPr bwMode="auto">
+          <a:xfrm>
+            <a:off x="7845200" y="2120000"/>
+            <a:ext cx="4000000" cy="450000"/>
+          </a:xfrm>
+          <a:prstGeom prst="rect">
+            <a:avLst/>
+          </a:prstGeom>
+          <a:noFill/>
+          <a:ln/>
+        </p:spPr>
+        <p:txBody>
+          <a:bodyPr wrap="square" lIns="0" tIns="0" rIns="0" bIns="0" rtlCol="0" anchor="t"/>
+          <a:lstStyle/>
+          <a:p>
+            <a:pPr marL="0" indent="0" algn="l">
+              <a:buNone/>
+              <a:defRPr/>
+            </a:pPr>
+            <a:r>
+              <a:rPr lang="it-IT" sz="1600" b="1" spc="300">
+                <a:solidFill>
+                  <a:srgbClr val="FF9B9B"/>
+                </a:solidFill>
+                <a:latin typeface="Open Sans"/>
+                <a:ea typeface="Open Sans"/>
+                <a:cs typeface="Open Sans"/>
+              </a:rPr>
+              <a:t>PER CHI</a:t>
+            </a:r>
+            <a:endParaRPr lang="it-IT"/>
+          </a:p>
+        </p:txBody>
+      </p:sp>
+      <p:sp>
+        <p:nvSpPr>
+          <p:cNvPr id="1211" name="Per Chi Text"/>
+          <p:cNvSpPr/>
+          <p:nvPr/>
+        </p:nvSpPr>
+        <p:spPr bwMode="auto">
+          <a:xfrm>
+            <a:off x="7845200" y="2800000"/>
+            <a:ext cx="5623680" cy="4000000"/>
+          </a:xfrm>
+          <a:prstGeom prst="rect">
+            <a:avLst/>
+          </a:prstGeom>
+          <a:noFill/>
+          <a:ln/>
+        </p:spPr>
+        <p:txBody>
+          <a:bodyPr wrap="square" lIns="0" tIns="0" rIns="0" bIns="0" rtlCol="0" anchor="t"/>
+          <a:lstStyle/>
+          <a:p>
+            <a:pPr marL="0" indent="0" algn="l">
+              <a:buNone/>
+              <a:defRPr/>
+            </a:pPr>
+            <a:r>
+              <a:rPr lang="it-IT" sz="2800">
+                <a:solidFill>
+                  <a:srgbClr val="F2EEFF"/>
+                </a:solidFill>
+                <a:latin typeface="Open Sans"/>
+                <a:ea typeface="Open Sans"/>
+                <a:cs typeface="Open Sans"/>
+              </a:rPr>
+              <a:t>Studenti in cerca di uno spazio tranquillo, lavoratori remoti, creativi.</a:t>
+            </a:r>
+            <a:endParaRPr lang="it-IT"/>
+          </a:p>
+        </p:txBody>
+      </p:sp>
+      <p:sp>
+        <p:nvSpPr>
+          <p:cNvPr id="1900" name="Watermark Cover"/>
+          <p:cNvSpPr/>
+          <p:nvPr/>
+        </p:nvSpPr>
+        <p:spPr bwMode="auto">
+          <a:xfrm>
+            <a:off x="12301840" y="7660956"/>
+            <a:ext cx="2371116" cy="526914"/>
+          </a:xfrm>
+          <a:prstGeom prst="rect">
+            <a:avLst/>
+          </a:prstGeom>
+          <a:solidFill>
+            <a:srgbClr val="14142E"/>
+          </a:solidFill>
+          <a:ln>
+            <a:noFill/>
+          </a:ln>
+        </p:spPr>
+      </p:sp>
+    </p:spTree>
+  </p:cSld>
+  <p:clrMapOvr>
+    <a:masterClrMapping/>
+  </p:clrMapOvr>
 </p:sld>
 </file>
 
@@ -3991,7 +4350,7 @@
             <a:r>
               <a:rPr lang="en-US" sz="4200" b="1">
                 <a:solidFill>
-                  <a:srgbClr val="403CCF"/>
+                  <a:srgbClr val="9A93F5"/>
                 </a:solidFill>
                 <a:latin typeface="Libre Baskerville"/>
                 <a:ea typeface="Libre Baskerville"/>
@@ -4020,11 +4379,11 @@
             </a:avLst>
           </a:prstGeom>
           <a:solidFill>
-            <a:srgbClr val="FBFAFF"/>
+            <a:srgbClr val="14142E"/>
           </a:solidFill>
           <a:ln w="22860">
             <a:solidFill>
-              <a:srgbClr val="D0CED9"/>
+              <a:srgbClr val="1A1A2E"/>
             </a:solidFill>
             <a:prstDash val="solid"/>
           </a:ln>
@@ -4083,7 +4442,7 @@
             <a:r>
               <a:rPr lang="en-US" sz="2600" b="1">
                 <a:solidFill>
-                  <a:srgbClr val="49495A"/>
+                  <a:srgbClr val="C4B8F5"/>
                 </a:solidFill>
                 <a:latin typeface="Libre Baskerville"/>
                 <a:ea typeface="Libre Baskerville"/>
@@ -4094,7 +4453,7 @@
             <a:r>
               <a:rPr lang="en-US" sz="2000">
                 <a:solidFill>
-                  <a:srgbClr val="49495A"/>
+                  <a:srgbClr val="C4B8F5"/>
                 </a:solidFill>
                 <a:latin typeface="Libre Baskerville"/>
                 <a:ea typeface="Libre Baskerville"/>
@@ -4105,7 +4464,7 @@
             <a:r>
               <a:rPr lang="en-US" sz="2000">
                 <a:solidFill>
-                  <a:srgbClr val="5955EB"/>
+                  <a:srgbClr val="ADA8F9"/>
                 </a:solidFill>
                 <a:latin typeface="Libre Baskerville"/>
                 <a:ea typeface="Libre Baskerville"/>
@@ -4148,7 +4507,7 @@
             <a:r>
               <a:rPr lang="en-US" sz="1800">
                 <a:solidFill>
-                  <a:srgbClr val="49495A"/>
+                  <a:srgbClr val="C4B8F5"/>
                 </a:solidFill>
                 <a:latin typeface="Open Sans"/>
                 <a:ea typeface="Open Sans"/>
@@ -4177,11 +4536,11 @@
             </a:avLst>
           </a:prstGeom>
           <a:solidFill>
-            <a:srgbClr val="FBFAFF"/>
+            <a:srgbClr val="14142E"/>
           </a:solidFill>
           <a:ln w="22860">
             <a:solidFill>
-              <a:srgbClr val="D0CED9"/>
+              <a:srgbClr val="1A1A2E"/>
             </a:solidFill>
             <a:prstDash val="solid"/>
           </a:ln>
@@ -4240,7 +4599,7 @@
             <a:r>
               <a:rPr lang="en-US" sz="2600" b="1">
                 <a:solidFill>
-                  <a:srgbClr val="49495A"/>
+                  <a:srgbClr val="C4B8F5"/>
                 </a:solidFill>
                 <a:latin typeface="Libre Baskerville"/>
                 <a:ea typeface="Libre Baskerville"/>
@@ -4251,7 +4610,7 @@
             <a:r>
               <a:rPr lang="en-US" sz="2200">
                 <a:solidFill>
-                  <a:srgbClr val="49495A"/>
+                  <a:srgbClr val="C4B8F5"/>
                 </a:solidFill>
                 <a:latin typeface="Libre Baskerville"/>
                 <a:ea typeface="Libre Baskerville"/>
@@ -4262,7 +4621,7 @@
             <a:r>
               <a:rPr lang="en-US" sz="2200">
                 <a:solidFill>
-                  <a:srgbClr val="5955EB"/>
+                  <a:srgbClr val="ADA8F9"/>
                 </a:solidFill>
                 <a:latin typeface="Libre Baskerville"/>
                 <a:ea typeface="Libre Baskerville"/>
@@ -4305,7 +4664,7 @@
             <a:r>
               <a:rPr lang="en-US" sz="1800">
                 <a:solidFill>
-                  <a:srgbClr val="49495A"/>
+                  <a:srgbClr val="C4B8F5"/>
                 </a:solidFill>
                 <a:latin typeface="Open Sans"/>
                 <a:ea typeface="Open Sans"/>
@@ -4334,11 +4693,11 @@
             </a:avLst>
           </a:prstGeom>
           <a:solidFill>
-            <a:srgbClr val="FBFAFF"/>
+            <a:srgbClr val="14142E"/>
           </a:solidFill>
           <a:ln w="22860">
             <a:solidFill>
-              <a:srgbClr val="D0CED9"/>
+              <a:srgbClr val="1A1A2E"/>
             </a:solidFill>
             <a:prstDash val="solid"/>
           </a:ln>
@@ -4397,7 +4756,7 @@
             <a:r>
               <a:rPr lang="en-US" sz="2600" b="1">
                 <a:solidFill>
-                  <a:srgbClr val="49495A"/>
+                  <a:srgbClr val="C4B8F5"/>
                 </a:solidFill>
                 <a:latin typeface="Libre Baskerville"/>
                 <a:ea typeface="Libre Baskerville"/>
@@ -4408,7 +4767,7 @@
             <a:r>
               <a:rPr lang="en-US" sz="2200">
                 <a:solidFill>
-                  <a:srgbClr val="49495A"/>
+                  <a:srgbClr val="C4B8F5"/>
                 </a:solidFill>
                 <a:latin typeface="Libre Baskerville"/>
                 <a:ea typeface="Libre Baskerville"/>
@@ -4419,7 +4778,7 @@
             <a:r>
               <a:rPr lang="en-US" sz="2200">
                 <a:solidFill>
-                  <a:srgbClr val="5955EB"/>
+                  <a:srgbClr val="ADA8F9"/>
                 </a:solidFill>
                 <a:latin typeface="Libre Baskerville"/>
                 <a:ea typeface="Libre Baskerville"/>
@@ -4462,7 +4821,7 @@
             <a:r>
               <a:rPr lang="en-US" sz="1800">
                 <a:solidFill>
-                  <a:srgbClr val="49495A"/>
+                  <a:srgbClr val="C4B8F5"/>
                 </a:solidFill>
                 <a:latin typeface="Open Sans"/>
                 <a:ea typeface="Open Sans"/>
@@ -4505,7 +4864,7 @@
             <a:r>
               <a:rPr lang="en-US" sz="1400" i="1">
                 <a:solidFill>
-                  <a:srgbClr val="49495A"/>
+                  <a:srgbClr val="C4B8F5"/>
                 </a:solidFill>
                 <a:latin typeface="Open Sans"/>
                 <a:ea typeface="Open Sans"/>
@@ -4534,7 +4893,7 @@
             </a:avLst>
           </a:prstGeom>
           <a:solidFill>
-            <a:srgbClr val="E7E0FF"/>
+            <a:srgbClr val="23213C"/>
           </a:solidFill>
           <a:ln/>
         </p:spPr>
@@ -4570,7 +4929,7 @@
             <a:r>
               <a:rPr lang="en-US" sz="1750">
                 <a:solidFill>
-                  <a:srgbClr val="000000"/>
+                  <a:srgbClr val="F2EEFF"/>
                 </a:solidFill>
                 <a:latin typeface="Libre Baskerville"/>
                 <a:ea typeface="Libre Baskerville"/>
@@ -4613,7 +4972,7 @@
             <a:r>
               <a:rPr lang="en-US" sz="1600">
                 <a:solidFill>
-                  <a:srgbClr val="49495A"/>
+                  <a:srgbClr val="C4B8F5"/>
                 </a:solidFill>
                 <a:latin typeface="Open Sans"/>
                 <a:ea typeface="Open Sans"/>
@@ -4656,7 +5015,7 @@
             <a:r>
               <a:rPr lang="en-US" sz="1700">
                 <a:solidFill>
-                  <a:srgbClr val="000000"/>
+                  <a:srgbClr val="F2EEFF"/>
                 </a:solidFill>
                 <a:latin typeface="Open Sans"/>
                 <a:ea typeface="Open Sans"/>
@@ -4667,7 +5026,7 @@
             <a:r>
               <a:rPr lang="en-US" sz="1700">
                 <a:solidFill>
-                  <a:srgbClr val="49495A"/>
+                  <a:srgbClr val="C4B8F5"/>
                 </a:solidFill>
                 <a:latin typeface="Open Sans"/>
                 <a:ea typeface="Open Sans"/>
@@ -4678,7 +5037,7 @@
             <a:r>
               <a:rPr lang="en-US" sz="1700" b="1">
                 <a:solidFill>
-                  <a:srgbClr val="49495A"/>
+                  <a:srgbClr val="C4B8F5"/>
                 </a:solidFill>
                 <a:latin typeface="Open Sans"/>
                 <a:ea typeface="Open Sans"/>
@@ -4689,7 +5048,7 @@
             <a:r>
               <a:rPr lang="en-US" sz="1700">
                 <a:solidFill>
-                  <a:srgbClr val="49495A"/>
+                  <a:srgbClr val="C4B8F5"/>
                 </a:solidFill>
                 <a:latin typeface="Open Sans"/>
                 <a:ea typeface="Open Sans"/>
@@ -4710,7 +5069,7 @@
             <a:r>
               <a:rPr lang="en-US" sz="1700">
                 <a:solidFill>
-                  <a:srgbClr val="000000"/>
+                  <a:srgbClr val="F2EEFF"/>
                 </a:solidFill>
                 <a:latin typeface="Open Sans"/>
                 <a:ea typeface="Open Sans"/>
@@ -4721,7 +5080,7 @@
             <a:r>
               <a:rPr lang="en-US" sz="1700">
                 <a:solidFill>
-                  <a:srgbClr val="49495A"/>
+                  <a:srgbClr val="C4B8F5"/>
                 </a:solidFill>
                 <a:latin typeface="Open Sans"/>
                 <a:ea typeface="Open Sans"/>
@@ -4732,7 +5091,7 @@
             <a:r>
               <a:rPr lang="en-US" sz="1700" b="1">
                 <a:solidFill>
-                  <a:srgbClr val="49495A"/>
+                  <a:srgbClr val="C4B8F5"/>
                 </a:solidFill>
                 <a:latin typeface="Open Sans"/>
                 <a:ea typeface="Open Sans"/>
@@ -4743,7 +5102,7 @@
             <a:r>
               <a:rPr lang="en-US" sz="1700">
                 <a:solidFill>
-                  <a:srgbClr val="49495A"/>
+                  <a:srgbClr val="C4B8F5"/>
                 </a:solidFill>
                 <a:latin typeface="Open Sans"/>
                 <a:ea typeface="Open Sans"/>
@@ -4764,7 +5123,7 @@
             <a:r>
               <a:rPr lang="en-US" sz="1700">
                 <a:solidFill>
-                  <a:srgbClr val="000000"/>
+                  <a:srgbClr val="F2EEFF"/>
                 </a:solidFill>
                 <a:latin typeface="Open Sans"/>
                 <a:ea typeface="Open Sans"/>
@@ -4775,7 +5134,7 @@
             <a:r>
               <a:rPr lang="en-US" sz="1700">
                 <a:solidFill>
-                  <a:srgbClr val="49495A"/>
+                  <a:srgbClr val="C4B8F5"/>
                 </a:solidFill>
                 <a:latin typeface="Open Sans"/>
                 <a:ea typeface="Open Sans"/>
@@ -4786,7 +5145,7 @@
             <a:r>
               <a:rPr lang="en-US" sz="1700" b="1">
                 <a:solidFill>
-                  <a:srgbClr val="49495A"/>
+                  <a:srgbClr val="C4B8F5"/>
                 </a:solidFill>
                 <a:latin typeface="Open Sans"/>
                 <a:ea typeface="Open Sans"/>
@@ -4797,7 +5156,7 @@
             <a:r>
               <a:rPr lang="en-US" sz="1700">
                 <a:solidFill>
-                  <a:srgbClr val="49495A"/>
+                  <a:srgbClr val="C4B8F5"/>
                 </a:solidFill>
                 <a:latin typeface="Open Sans"/>
                 <a:ea typeface="Open Sans"/>
@@ -4818,7 +5177,7 @@
             <a:r>
               <a:rPr lang="en-US" sz="1700">
                 <a:solidFill>
-                  <a:srgbClr val="000000"/>
+                  <a:srgbClr val="F2EEFF"/>
                 </a:solidFill>
                 <a:latin typeface="Open Sans"/>
                 <a:ea typeface="Open Sans"/>
@@ -4829,7 +5188,7 @@
             <a:r>
               <a:rPr lang="en-US" sz="1700">
                 <a:solidFill>
-                  <a:srgbClr val="49495A"/>
+                  <a:srgbClr val="C4B8F5"/>
                 </a:solidFill>
                 <a:latin typeface="Open Sans"/>
                 <a:ea typeface="Open Sans"/>
@@ -4840,7 +5199,7 @@
             <a:r>
               <a:rPr lang="en-US" sz="1700" b="1">
                 <a:solidFill>
-                  <a:srgbClr val="49495A"/>
+                  <a:srgbClr val="C4B8F5"/>
                 </a:solidFill>
                 <a:latin typeface="Open Sans"/>
                 <a:ea typeface="Open Sans"/>
@@ -4851,7 +5210,7 @@
             <a:r>
               <a:rPr lang="en-US" sz="1700">
                 <a:solidFill>
-                  <a:srgbClr val="49495A"/>
+                  <a:srgbClr val="C4B8F5"/>
                 </a:solidFill>
                 <a:latin typeface="Open Sans"/>
                 <a:ea typeface="Open Sans"/>
@@ -4872,7 +5231,7 @@
             <a:r>
               <a:rPr lang="en-US" sz="1700">
                 <a:solidFill>
-                  <a:srgbClr val="000000"/>
+                  <a:srgbClr val="F2EEFF"/>
                 </a:solidFill>
                 <a:latin typeface="Open Sans"/>
                 <a:ea typeface="Open Sans"/>
@@ -4883,7 +5242,7 @@
             <a:r>
               <a:rPr lang="en-US" sz="1700">
                 <a:solidFill>
-                  <a:srgbClr val="49495A"/>
+                  <a:srgbClr val="C4B8F5"/>
                 </a:solidFill>
                 <a:latin typeface="Open Sans"/>
                 <a:ea typeface="Open Sans"/>
@@ -4894,7 +5253,7 @@
             <a:r>
               <a:rPr lang="en-US" sz="1700" b="1">
                 <a:solidFill>
-                  <a:srgbClr val="49495A"/>
+                  <a:srgbClr val="C4B8F5"/>
                 </a:solidFill>
                 <a:latin typeface="Open Sans"/>
                 <a:ea typeface="Open Sans"/>
@@ -4905,7 +5264,7 @@
             <a:r>
               <a:rPr lang="en-US" sz="1700">
                 <a:solidFill>
-                  <a:srgbClr val="49495A"/>
+                  <a:srgbClr val="C4B8F5"/>
                 </a:solidFill>
                 <a:latin typeface="Open Sans"/>
                 <a:ea typeface="Open Sans"/>
@@ -4926,7 +5285,7 @@
             <a:r>
               <a:rPr lang="en-US" sz="1700">
                 <a:solidFill>
-                  <a:srgbClr val="000000"/>
+                  <a:srgbClr val="F2EEFF"/>
                 </a:solidFill>
                 <a:latin typeface="Open Sans"/>
                 <a:ea typeface="Open Sans"/>
@@ -4937,7 +5296,7 @@
             <a:r>
               <a:rPr lang="en-US" sz="1700">
                 <a:solidFill>
-                  <a:srgbClr val="49495A"/>
+                  <a:srgbClr val="C4B8F5"/>
                 </a:solidFill>
                 <a:latin typeface="Open Sans"/>
                 <a:ea typeface="Open Sans"/>
@@ -4948,7 +5307,7 @@
             <a:r>
               <a:rPr lang="en-US" sz="1700" b="1">
                 <a:solidFill>
-                  <a:srgbClr val="49495A"/>
+                  <a:srgbClr val="C4B8F5"/>
                 </a:solidFill>
                 <a:latin typeface="Open Sans"/>
                 <a:ea typeface="Open Sans"/>
@@ -4959,7 +5318,7 @@
             <a:r>
               <a:rPr lang="en-US" sz="1700">
                 <a:solidFill>
-                  <a:srgbClr val="49495A"/>
+                  <a:srgbClr val="C4B8F5"/>
                 </a:solidFill>
                 <a:latin typeface="Open Sans"/>
                 <a:ea typeface="Open Sans"/>
@@ -5002,7 +5361,7 @@
             <a:r>
               <a:rPr lang="en-US" sz="1500" i="1">
                 <a:solidFill>
-                  <a:srgbClr val="49495A"/>
+                  <a:srgbClr val="C4B8F5"/>
                 </a:solidFill>
                 <a:latin typeface="Open Sans"/>
                 <a:ea typeface="Open Sans"/>
@@ -5029,7 +5388,7 @@
             <a:avLst/>
           </a:prstGeom>
           <a:solidFill>
-            <a:srgbClr val="403CCF"/>
+            <a:srgbClr val="5A52DC"/>
           </a:solidFill>
           <a:ln/>
         </p:spPr>
@@ -5049,7 +5408,7 @@
             <a:avLst/>
           </a:prstGeom>
           <a:solidFill>
-            <a:schemeClr val="bg1"/>
+            <a:srgbClr val="14142E"/>
           </a:solidFill>
           <a:ln w="12700" cap="flat" cmpd="sng" algn="ctr">
             <a:noFill/>
@@ -5112,7 +5471,7 @@
     <p:bg>
       <p:bgPr shadeToTitle="0">
         <a:solidFill>
-          <a:schemeClr val="bg1"/>
+          <a:srgbClr val="14142E"/>
         </a:solidFill>
       </p:bgPr>
     </p:bg>
@@ -5158,7 +5517,7 @@
             <a:r>
               <a:rPr lang="en-US" sz="4200" b="1">
                 <a:solidFill>
-                  <a:srgbClr val="4F46E5"/>
+                  <a:srgbClr val="A7A0F8"/>
                 </a:solidFill>
                 <a:latin typeface="Open Sans"/>
                 <a:ea typeface="Open Sans"/>
@@ -5198,7 +5557,7 @@
             <a:r>
               <a:rPr lang="en-US" sz="2600" b="1" i="1">
                 <a:solidFill>
-                  <a:srgbClr val="1F1F2E"/>
+                  <a:srgbClr val="E7E0FF"/>
                 </a:solidFill>
                 <a:latin typeface="Open Sans"/>
                 <a:ea typeface="Open Sans"/>
@@ -5227,11 +5586,11 @@
             </a:avLst>
           </a:prstGeom>
           <a:solidFill>
-            <a:srgbClr val="4F46E5"/>
+            <a:srgbClr val="635AE8"/>
           </a:solidFill>
           <a:ln w="19050">
             <a:solidFill>
-              <a:srgbClr val="4F46E5"/>
+              <a:srgbClr val="635AE8"/>
             </a:solidFill>
             <a:prstDash val="solid"/>
           </a:ln>
@@ -5334,11 +5693,11 @@
             </a:avLst>
           </a:prstGeom>
           <a:solidFill>
-            <a:srgbClr val="ECEBFA"/>
+            <a:srgbClr val="1A1A2E"/>
           </a:solidFill>
           <a:ln w="19050">
             <a:solidFill>
-              <a:srgbClr val="C4B8F5"/>
+              <a:srgbClr val="3B337A"/>
             </a:solidFill>
             <a:prstDash val="solid"/>
           </a:ln>
@@ -5372,7 +5731,7 @@
             <a:r>
               <a:rPr lang="en-US" sz="5600" b="1">
                 <a:solidFill>
-                  <a:srgbClr val="4F46E5"/>
+                  <a:srgbClr val="A7A0F8"/>
                 </a:solidFill>
                 <a:latin typeface="Open Sans"/>
                 <a:ea typeface="Open Sans"/>
@@ -5412,7 +5771,7 @@
             <a:r>
               <a:rPr lang="en-US" sz="1400">
                 <a:solidFill>
-                  <a:srgbClr val="49495A"/>
+                  <a:srgbClr val="C4B8F5"/>
                 </a:solidFill>
                 <a:latin typeface="Open Sans"/>
                 <a:ea typeface="Open Sans"/>
@@ -5441,11 +5800,11 @@
             </a:avLst>
           </a:prstGeom>
           <a:solidFill>
-            <a:srgbClr val="ECEBFA"/>
+            <a:srgbClr val="1A1A2E"/>
           </a:solidFill>
           <a:ln w="19050">
             <a:solidFill>
-              <a:srgbClr val="C4B8F5"/>
+              <a:srgbClr val="3B337A"/>
             </a:solidFill>
             <a:prstDash val="solid"/>
           </a:ln>
@@ -5479,7 +5838,7 @@
             <a:r>
               <a:rPr lang="en-US" sz="5600" b="1">
                 <a:solidFill>
-                  <a:srgbClr val="4F46E5"/>
+                  <a:srgbClr val="A7A0F8"/>
                 </a:solidFill>
                 <a:latin typeface="Open Sans"/>
                 <a:ea typeface="Open Sans"/>
@@ -5519,7 +5878,7 @@
             <a:r>
               <a:rPr lang="en-US" sz="1400">
                 <a:solidFill>
-                  <a:srgbClr val="49495A"/>
+                  <a:srgbClr val="C4B8F5"/>
                 </a:solidFill>
                 <a:latin typeface="Open Sans"/>
                 <a:ea typeface="Open Sans"/>
@@ -5548,11 +5907,11 @@
             </a:avLst>
           </a:prstGeom>
           <a:solidFill>
-            <a:srgbClr val="ECEBFA"/>
+            <a:srgbClr val="1A1A2E"/>
           </a:solidFill>
           <a:ln w="19050">
             <a:solidFill>
-              <a:srgbClr val="C4B8F5"/>
+              <a:srgbClr val="3B337A"/>
             </a:solidFill>
             <a:prstDash val="solid"/>
           </a:ln>
@@ -5586,7 +5945,7 @@
             <a:r>
               <a:rPr lang="en-US" sz="2200" b="1">
                 <a:solidFill>
-                  <a:srgbClr val="1F1F2E"/>
+                  <a:srgbClr val="E7E0FF"/>
                 </a:solidFill>
                 <a:latin typeface="Open Sans"/>
                 <a:ea typeface="Open Sans"/>
@@ -5597,7 +5956,7 @@
             <a:br>
               <a:rPr lang="en-US" sz="1800" b="1">
                 <a:solidFill>
-                  <a:srgbClr val="1F1F2E"/>
+                  <a:srgbClr val="E7E0FF"/>
                 </a:solidFill>
                 <a:latin typeface="Open Sans"/>
                 <a:ea typeface="Open Sans"/>
@@ -5607,7 +5966,7 @@
             <a:r>
               <a:rPr lang="en-US" sz="1800">
                 <a:solidFill>
-                  <a:srgbClr val="49495A"/>
+                  <a:srgbClr val="C4B8F5"/>
                 </a:solidFill>
                 <a:latin typeface="Open Sans"/>
                 <a:ea typeface="Open Sans"/>
@@ -5647,7 +6006,7 @@
             <a:r>
               <a:rPr lang="en-US" sz="1600" b="1">
                 <a:solidFill>
-                  <a:srgbClr val="1F1F2E"/>
+                  <a:srgbClr val="E7E0FF"/>
                 </a:solidFill>
                 <a:latin typeface="Open Sans"/>
                 <a:ea typeface="Open Sans"/>
@@ -5658,7 +6017,7 @@
             <a:r>
               <a:rPr lang="en-US" sz="1600">
                 <a:solidFill>
-                  <a:srgbClr val="49495A"/>
+                  <a:srgbClr val="C4B8F5"/>
                 </a:solidFill>
                 <a:latin typeface="Open Sans"/>
                 <a:ea typeface="Open Sans"/>
@@ -5687,7 +6046,7 @@
           <a:noFill/>
           <a:ln w="12700">
             <a:solidFill>
-              <a:srgbClr val="C4B8F5"/>
+              <a:srgbClr val="3B337A"/>
             </a:solidFill>
             <a:prstDash val="solid"/>
           </a:ln>
@@ -5721,7 +6080,7 @@
             <a:r>
               <a:rPr lang="en-US" sz="2600" b="1" i="1">
                 <a:solidFill>
-                  <a:srgbClr val="1F1F2E"/>
+                  <a:srgbClr val="E7E0FF"/>
                 </a:solidFill>
                 <a:latin typeface="Open Sans"/>
                 <a:ea typeface="Open Sans"/>
@@ -5761,7 +6120,7 @@
             <a:r>
               <a:rPr lang="en-US" sz="4000" b="1">
                 <a:solidFill>
-                  <a:srgbClr val="4F46E5"/>
+                  <a:srgbClr val="A7A0F8"/>
                 </a:solidFill>
                 <a:latin typeface="Open Sans"/>
                 <a:ea typeface="Open Sans"/>
@@ -5772,7 +6131,7 @@
             <a:r>
               <a:rPr lang="en-US" sz="1800">
                 <a:solidFill>
-                  <a:srgbClr val="49495A"/>
+                  <a:srgbClr val="C4B8F5"/>
                 </a:solidFill>
                 <a:latin typeface="Open Sans"/>
                 <a:ea typeface="Open Sans"/>
@@ -5783,7 +6142,7 @@
             <a:r>
               <a:rPr lang="en-US" sz="2000">
                 <a:solidFill>
-                  <a:srgbClr val="49495A"/>
+                  <a:srgbClr val="C4B8F5"/>
                 </a:solidFill>
                 <a:latin typeface="Open Sans"/>
                 <a:ea typeface="Open Sans"/>
@@ -5794,7 +6153,7 @@
             <a:r>
               <a:rPr lang="en-US" sz="1800">
                 <a:solidFill>
-                  <a:srgbClr val="49495A"/>
+                  <a:srgbClr val="C4B8F5"/>
                 </a:solidFill>
                 <a:latin typeface="Open Sans"/>
                 <a:ea typeface="Open Sans"/>
@@ -5805,7 +6164,7 @@
             <a:r>
               <a:rPr lang="en-US" sz="4000" b="1">
                 <a:solidFill>
-                  <a:srgbClr val="4F46E5"/>
+                  <a:srgbClr val="A7A0F8"/>
                 </a:solidFill>
                 <a:latin typeface="Open Sans"/>
                 <a:ea typeface="Open Sans"/>
@@ -5816,7 +6175,7 @@
             <a:r>
               <a:rPr lang="en-US" sz="1800">
                 <a:solidFill>
-                  <a:srgbClr val="49495A"/>
+                  <a:srgbClr val="C4B8F5"/>
                 </a:solidFill>
                 <a:latin typeface="Open Sans"/>
                 <a:ea typeface="Open Sans"/>
@@ -5827,7 +6186,7 @@
             <a:r>
               <a:rPr lang="en-US" sz="2000">
                 <a:solidFill>
-                  <a:srgbClr val="49495A"/>
+                  <a:srgbClr val="C4B8F5"/>
                 </a:solidFill>
                 <a:latin typeface="Open Sans"/>
                 <a:ea typeface="Open Sans"/>
@@ -5867,7 +6226,7 @@
             <a:r>
               <a:rPr lang="en-US" sz="1500">
                 <a:solidFill>
-                  <a:srgbClr val="1F1F2E"/>
+                  <a:srgbClr val="E7E0FF"/>
                 </a:solidFill>
                 <a:latin typeface="Open Sans"/>
                 <a:ea typeface="Open Sans"/>
@@ -5896,11 +6255,11 @@
             </a:avLst>
           </a:prstGeom>
           <a:solidFill>
-            <a:srgbClr val="4F46E5"/>
+            <a:srgbClr val="635AE8"/>
           </a:solidFill>
           <a:ln w="12700">
             <a:solidFill>
-              <a:srgbClr val="4F46E5"/>
+              <a:srgbClr val="635AE8"/>
             </a:solidFill>
             <a:prstDash val="solid"/>
           </a:ln>
@@ -5934,7 +6293,7 @@
             <a:r>
               <a:rPr lang="en-US" sz="1500" b="1">
                 <a:solidFill>
-                  <a:srgbClr val="1F1F2E"/>
+                  <a:srgbClr val="E7E0FF"/>
                 </a:solidFill>
                 <a:latin typeface="Open Sans"/>
                 <a:ea typeface="Open Sans"/>
@@ -5974,7 +6333,7 @@
             <a:r>
               <a:rPr lang="en-US" sz="1500">
                 <a:solidFill>
-                  <a:srgbClr val="1F1F2E"/>
+                  <a:srgbClr val="E7E0FF"/>
                 </a:solidFill>
                 <a:latin typeface="Open Sans"/>
                 <a:ea typeface="Open Sans"/>
@@ -6003,11 +6362,11 @@
             </a:avLst>
           </a:prstGeom>
           <a:solidFill>
-            <a:srgbClr val="4F46E5"/>
+            <a:srgbClr val="635AE8"/>
           </a:solidFill>
           <a:ln w="12700">
             <a:solidFill>
-              <a:srgbClr val="4F46E5"/>
+              <a:srgbClr val="635AE8"/>
             </a:solidFill>
             <a:prstDash val="solid"/>
           </a:ln>
@@ -6041,7 +6400,7 @@
             <a:r>
               <a:rPr lang="en-US" sz="1500" b="1">
                 <a:solidFill>
-                  <a:srgbClr val="1F1F2E"/>
+                  <a:srgbClr val="E7E0FF"/>
                 </a:solidFill>
                 <a:latin typeface="Open Sans"/>
                 <a:ea typeface="Open Sans"/>
@@ -6081,7 +6440,7 @@
             <a:r>
               <a:rPr lang="en-US" sz="1500">
                 <a:solidFill>
-                  <a:srgbClr val="1F1F2E"/>
+                  <a:srgbClr val="E7E0FF"/>
                 </a:solidFill>
                 <a:latin typeface="Open Sans"/>
                 <a:ea typeface="Open Sans"/>
@@ -6110,11 +6469,11 @@
             </a:avLst>
           </a:prstGeom>
           <a:solidFill>
-            <a:srgbClr val="4F46E5"/>
+            <a:srgbClr val="635AE8"/>
           </a:solidFill>
           <a:ln w="12700">
             <a:solidFill>
-              <a:srgbClr val="4F46E5"/>
+              <a:srgbClr val="635AE8"/>
             </a:solidFill>
             <a:prstDash val="solid"/>
           </a:ln>
@@ -6148,7 +6507,7 @@
             <a:r>
               <a:rPr lang="en-US" sz="1500" b="1">
                 <a:solidFill>
-                  <a:srgbClr val="1F1F2E"/>
+                  <a:srgbClr val="E7E0FF"/>
                 </a:solidFill>
                 <a:latin typeface="Open Sans"/>
                 <a:ea typeface="Open Sans"/>
@@ -6188,7 +6547,7 @@
             <a:r>
               <a:rPr lang="en-US" sz="1500">
                 <a:solidFill>
-                  <a:srgbClr val="1F1F2E"/>
+                  <a:srgbClr val="E7E0FF"/>
                 </a:solidFill>
                 <a:latin typeface="Open Sans"/>
                 <a:ea typeface="Open Sans"/>
@@ -6217,11 +6576,11 @@
             </a:avLst>
           </a:prstGeom>
           <a:solidFill>
-            <a:srgbClr val="4F46E5"/>
+            <a:srgbClr val="635AE8"/>
           </a:solidFill>
           <a:ln w="12700">
             <a:solidFill>
-              <a:srgbClr val="4F46E5"/>
+              <a:srgbClr val="635AE8"/>
             </a:solidFill>
             <a:prstDash val="solid"/>
           </a:ln>
@@ -6255,7 +6614,7 @@
             <a:r>
               <a:rPr lang="en-US" sz="1500" b="1">
                 <a:solidFill>
-                  <a:srgbClr val="1F1F2E"/>
+                  <a:srgbClr val="E7E0FF"/>
                 </a:solidFill>
                 <a:latin typeface="Open Sans"/>
                 <a:ea typeface="Open Sans"/>
@@ -6295,7 +6654,7 @@
             <a:r>
               <a:rPr lang="en-US" sz="1500">
                 <a:solidFill>
-                  <a:srgbClr val="1F1F2E"/>
+                  <a:srgbClr val="E7E0FF"/>
                 </a:solidFill>
                 <a:latin typeface="Open Sans"/>
                 <a:ea typeface="Open Sans"/>
@@ -6324,11 +6683,11 @@
             </a:avLst>
           </a:prstGeom>
           <a:solidFill>
-            <a:srgbClr val="4F46E5"/>
+            <a:srgbClr val="635AE8"/>
           </a:solidFill>
           <a:ln w="12700">
             <a:solidFill>
-              <a:srgbClr val="4F46E5"/>
+              <a:srgbClr val="635AE8"/>
             </a:solidFill>
             <a:prstDash val="solid"/>
           </a:ln>
@@ -6362,7 +6721,7 @@
             <a:r>
               <a:rPr lang="en-US" sz="1500" b="1">
                 <a:solidFill>
-                  <a:srgbClr val="1F1F2E"/>
+                  <a:srgbClr val="E7E0FF"/>
                 </a:solidFill>
                 <a:latin typeface="Open Sans"/>
                 <a:ea typeface="Open Sans"/>
@@ -6402,7 +6761,7 @@
             <a:r>
               <a:rPr lang="en-US" sz="1500">
                 <a:solidFill>
-                  <a:srgbClr val="1F1F2E"/>
+                  <a:srgbClr val="E7E0FF"/>
                 </a:solidFill>
                 <a:latin typeface="Open Sans"/>
                 <a:ea typeface="Open Sans"/>
@@ -6431,11 +6790,11 @@
             </a:avLst>
           </a:prstGeom>
           <a:solidFill>
-            <a:srgbClr val="7B6FE8"/>
+            <a:srgbClr val="8F88F0"/>
           </a:solidFill>
           <a:ln w="12700">
             <a:solidFill>
-              <a:srgbClr val="7B6FE8"/>
+              <a:srgbClr val="8F88F0"/>
             </a:solidFill>
             <a:prstDash val="solid"/>
           </a:ln>
@@ -6469,7 +6828,7 @@
             <a:r>
               <a:rPr lang="en-US" sz="1500" b="1">
                 <a:solidFill>
-                  <a:srgbClr val="1F1F2E"/>
+                  <a:srgbClr val="E7E0FF"/>
                 </a:solidFill>
                 <a:latin typeface="Open Sans"/>
                 <a:ea typeface="Open Sans"/>
@@ -6496,7 +6855,7 @@
             <a:avLst/>
           </a:prstGeom>
           <a:solidFill>
-            <a:schemeClr val="bg1"/>
+            <a:srgbClr val="14142E"/>
           </a:solidFill>
           <a:ln w="12700" cap="flat" cmpd="sng" algn="ctr">
             <a:noFill/>
@@ -6601,7 +6960,7 @@
             <a:r>
               <a:rPr lang="en-US" sz="4200" b="1">
                 <a:solidFill>
-                  <a:srgbClr val="403CCF"/>
+                  <a:srgbClr val="9A93F5"/>
                 </a:solidFill>
                 <a:latin typeface="Libre Baskerville"/>
                 <a:ea typeface="Libre Baskerville"/>
@@ -6644,7 +7003,7 @@
             <a:r>
               <a:rPr lang="en-US" sz="2000" i="1">
                 <a:solidFill>
-                  <a:srgbClr val="49495A"/>
+                  <a:srgbClr val="C4B8F5"/>
                 </a:solidFill>
                 <a:latin typeface="Open Sans"/>
                 <a:ea typeface="Open Sans"/>
@@ -6671,7 +7030,7 @@
             <a:avLst/>
           </a:prstGeom>
           <a:solidFill>
-            <a:srgbClr val="403CCF"/>
+            <a:srgbClr val="5A52DC"/>
           </a:solidFill>
           <a:ln/>
         </p:spPr>
@@ -6707,7 +7066,7 @@
             <a:r>
               <a:rPr lang="en-US" sz="2400" b="1">
                 <a:solidFill>
-                  <a:srgbClr val="403CCF"/>
+                  <a:srgbClr val="9A93F5"/>
                 </a:solidFill>
                 <a:latin typeface="Libre Baskerville"/>
                 <a:ea typeface="Libre Baskerville"/>
@@ -6778,7 +7137,7 @@
             <a:r>
               <a:rPr lang="en-US" sz="2000" b="1">
                 <a:solidFill>
-                  <a:srgbClr val="000000"/>
+                  <a:srgbClr val="F2EEFF"/>
                 </a:solidFill>
                 <a:latin typeface="Libre Baskerville"/>
                 <a:ea typeface="Libre Baskerville"/>
@@ -6789,7 +7148,7 @@
             <a:r>
               <a:rPr lang="en-US" sz="2000" b="1">
                 <a:solidFill>
-                  <a:srgbClr val="49495A"/>
+                  <a:srgbClr val="C4B8F5"/>
                 </a:solidFill>
                 <a:latin typeface="Libre Baskerville"/>
                 <a:ea typeface="Libre Baskerville"/>
@@ -6832,7 +7191,7 @@
             <a:r>
               <a:rPr lang="en-US" sz="1700">
                 <a:solidFill>
-                  <a:srgbClr val="49495A"/>
+                  <a:srgbClr val="C4B8F5"/>
                 </a:solidFill>
                 <a:latin typeface="Open Sans"/>
                 <a:ea typeface="Open Sans"/>
@@ -6897,7 +7256,7 @@
             <a:r>
               <a:rPr lang="en-US" sz="2000" b="1">
                 <a:solidFill>
-                  <a:srgbClr val="000000"/>
+                  <a:srgbClr val="F2EEFF"/>
                 </a:solidFill>
                 <a:latin typeface="Libre Baskerville"/>
                 <a:ea typeface="Libre Baskerville"/>
@@ -6908,7 +7267,7 @@
             <a:r>
               <a:rPr lang="en-US" sz="2000" b="1">
                 <a:solidFill>
-                  <a:srgbClr val="49495A"/>
+                  <a:srgbClr val="C4B8F5"/>
                 </a:solidFill>
                 <a:latin typeface="Libre Baskerville"/>
                 <a:ea typeface="Libre Baskerville"/>
@@ -6951,7 +7310,7 @@
             <a:r>
               <a:rPr lang="en-US" sz="1700">
                 <a:solidFill>
-                  <a:srgbClr val="49495A"/>
+                  <a:srgbClr val="C4B8F5"/>
                 </a:solidFill>
                 <a:latin typeface="Open Sans"/>
                 <a:ea typeface="Open Sans"/>
@@ -7016,7 +7375,7 @@
             <a:r>
               <a:rPr lang="en-US" sz="2000" b="1">
                 <a:solidFill>
-                  <a:srgbClr val="000000"/>
+                  <a:srgbClr val="F2EEFF"/>
                 </a:solidFill>
                 <a:latin typeface="Libre Baskerville"/>
                 <a:ea typeface="Libre Baskerville"/>
@@ -7027,7 +7386,7 @@
             <a:r>
               <a:rPr lang="en-US" sz="2000" b="1">
                 <a:solidFill>
-                  <a:srgbClr val="49495A"/>
+                  <a:srgbClr val="C4B8F5"/>
                 </a:solidFill>
                 <a:latin typeface="Libre Baskerville"/>
                 <a:ea typeface="Libre Baskerville"/>
@@ -7070,7 +7429,7 @@
             <a:r>
               <a:rPr lang="en-US" sz="1700">
                 <a:solidFill>
-                  <a:srgbClr val="49495A"/>
+                  <a:srgbClr val="C4B8F5"/>
                 </a:solidFill>
                 <a:latin typeface="Open Sans"/>
                 <a:ea typeface="Open Sans"/>
@@ -7135,7 +7494,7 @@
             <a:r>
               <a:rPr lang="en-US" sz="2000" b="1">
                 <a:solidFill>
-                  <a:srgbClr val="000000"/>
+                  <a:srgbClr val="F2EEFF"/>
                 </a:solidFill>
                 <a:latin typeface="Libre Baskerville"/>
                 <a:ea typeface="Libre Baskerville"/>
@@ -7146,7 +7505,7 @@
             <a:r>
               <a:rPr lang="en-US" sz="2000" b="1">
                 <a:solidFill>
-                  <a:srgbClr val="49495A"/>
+                  <a:srgbClr val="C4B8F5"/>
                 </a:solidFill>
                 <a:latin typeface="Libre Baskerville"/>
                 <a:ea typeface="Libre Baskerville"/>
@@ -7189,7 +7548,7 @@
             <a:r>
               <a:rPr lang="en-US" sz="1700">
                 <a:solidFill>
-                  <a:srgbClr val="49495A"/>
+                  <a:srgbClr val="C4B8F5"/>
                 </a:solidFill>
                 <a:latin typeface="Open Sans"/>
                 <a:ea typeface="Open Sans"/>
@@ -7254,7 +7613,7 @@
             <a:r>
               <a:rPr lang="en-US" sz="2000" b="1">
                 <a:solidFill>
-                  <a:srgbClr val="000000"/>
+                  <a:srgbClr val="F2EEFF"/>
                 </a:solidFill>
                 <a:latin typeface="Libre Baskerville"/>
                 <a:ea typeface="Libre Baskerville"/>
@@ -7265,7 +7624,7 @@
             <a:r>
               <a:rPr lang="en-US" sz="2000" b="1">
                 <a:solidFill>
-                  <a:srgbClr val="49495A"/>
+                  <a:srgbClr val="C4B8F5"/>
                 </a:solidFill>
                 <a:latin typeface="Libre Baskerville"/>
                 <a:ea typeface="Libre Baskerville"/>
@@ -7276,7 +7635,7 @@
             <a:r>
               <a:rPr lang="en-US" sz="2000" b="1">
                 <a:solidFill>
-                  <a:srgbClr val="49495A"/>
+                  <a:srgbClr val="C4B8F5"/>
                 </a:solidFill>
                 <a:latin typeface="Libre Baskerville"/>
                 <a:ea typeface="Libre Baskerville"/>
@@ -7319,7 +7678,7 @@
             <a:r>
               <a:rPr lang="en-US" sz="1700">
                 <a:solidFill>
-                  <a:srgbClr val="49495A"/>
+                  <a:srgbClr val="C4B8F5"/>
                 </a:solidFill>
                 <a:latin typeface="Open Sans"/>
                 <a:ea typeface="Open Sans"/>
@@ -7384,7 +7743,7 @@
             <a:r>
               <a:rPr lang="en-US" sz="2000" b="1">
                 <a:solidFill>
-                  <a:srgbClr val="000000"/>
+                  <a:srgbClr val="F2EEFF"/>
                 </a:solidFill>
                 <a:latin typeface="Libre Baskerville"/>
                 <a:ea typeface="Libre Baskerville"/>
@@ -7395,7 +7754,7 @@
             <a:r>
               <a:rPr lang="en-US" sz="2000" b="1">
                 <a:solidFill>
-                  <a:srgbClr val="49495A"/>
+                  <a:srgbClr val="C4B8F5"/>
                 </a:solidFill>
                 <a:latin typeface="Libre Baskerville"/>
                 <a:ea typeface="Libre Baskerville"/>
@@ -7438,7 +7797,7 @@
             <a:r>
               <a:rPr lang="en-US" sz="1700">
                 <a:solidFill>
-                  <a:srgbClr val="49495A"/>
+                  <a:srgbClr val="C4B8F5"/>
                 </a:solidFill>
                 <a:latin typeface="Open Sans"/>
                 <a:ea typeface="Open Sans"/>
@@ -7481,7 +7840,7 @@
             <a:r>
               <a:rPr lang="en-US" sz="2400" b="1">
                 <a:solidFill>
-                  <a:srgbClr val="403CCF"/>
+                  <a:srgbClr val="9A93F5"/>
                 </a:solidFill>
                 <a:latin typeface="Libre Baskerville"/>
                 <a:ea typeface="Libre Baskerville"/>
@@ -7510,11 +7869,11 @@
             </a:avLst>
           </a:prstGeom>
           <a:solidFill>
-            <a:srgbClr val="FBFAFF"/>
+            <a:srgbClr val="14142E"/>
           </a:solidFill>
           <a:ln w="15240">
             <a:solidFill>
-              <a:srgbClr val="D0CED9"/>
+              <a:srgbClr val="1A1A2E"/>
             </a:solidFill>
             <a:prstDash val="solid"/>
           </a:ln>
@@ -7573,7 +7932,7 @@
             <a:r>
               <a:rPr lang="en-US" sz="1800" b="1">
                 <a:solidFill>
-                  <a:srgbClr val="49495A"/>
+                  <a:srgbClr val="C4B8F5"/>
                 </a:solidFill>
                 <a:latin typeface="Libre Baskerville"/>
                 <a:ea typeface="Libre Baskerville"/>
@@ -7584,7 +7943,7 @@
             <a:r>
               <a:rPr lang="en-US" sz="1800" b="1">
                 <a:solidFill>
-                  <a:srgbClr val="49495A"/>
+                  <a:srgbClr val="C4B8F5"/>
                 </a:solidFill>
                 <a:latin typeface="Libre Baskerville"/>
                 <a:ea typeface="Libre Baskerville"/>
@@ -7627,7 +7986,7 @@
             <a:r>
               <a:rPr lang="en-US" sz="1500">
                 <a:solidFill>
-                  <a:srgbClr val="49495A"/>
+                  <a:srgbClr val="C4B8F5"/>
                 </a:solidFill>
                 <a:latin typeface="Open Sans"/>
                 <a:ea typeface="Open Sans"/>
@@ -7656,11 +8015,11 @@
             </a:avLst>
           </a:prstGeom>
           <a:solidFill>
-            <a:srgbClr val="FBFAFF"/>
+            <a:srgbClr val="14142E"/>
           </a:solidFill>
           <a:ln w="15240">
             <a:solidFill>
-              <a:srgbClr val="D0CED9"/>
+              <a:srgbClr val="1A1A2E"/>
             </a:solidFill>
             <a:prstDash val="solid"/>
           </a:ln>
@@ -7719,7 +8078,7 @@
             <a:r>
               <a:rPr lang="en-US" sz="1800" b="1">
                 <a:solidFill>
-                  <a:srgbClr val="49495A"/>
+                  <a:srgbClr val="C4B8F5"/>
                 </a:solidFill>
                 <a:latin typeface="Libre Baskerville"/>
                 <a:ea typeface="Libre Baskerville"/>
@@ -7762,7 +8121,7 @@
             <a:r>
               <a:rPr lang="en-US" sz="1500">
                 <a:solidFill>
-                  <a:srgbClr val="49495A"/>
+                  <a:srgbClr val="C4B8F5"/>
                 </a:solidFill>
                 <a:latin typeface="Open Sans"/>
                 <a:ea typeface="Open Sans"/>
@@ -7791,11 +8150,11 @@
             </a:avLst>
           </a:prstGeom>
           <a:solidFill>
-            <a:srgbClr val="FBFAFF"/>
+            <a:srgbClr val="14142E"/>
           </a:solidFill>
           <a:ln w="15240">
             <a:solidFill>
-              <a:srgbClr val="D0CED9"/>
+              <a:srgbClr val="1A1A2E"/>
             </a:solidFill>
             <a:prstDash val="solid"/>
           </a:ln>
@@ -7854,7 +8213,7 @@
             <a:r>
               <a:rPr lang="en-US" sz="1800" b="1">
                 <a:solidFill>
-                  <a:srgbClr val="49495A"/>
+                  <a:srgbClr val="C4B8F5"/>
                 </a:solidFill>
                 <a:latin typeface="Libre Baskerville"/>
                 <a:ea typeface="Libre Baskerville"/>
@@ -7897,7 +8256,7 @@
             <a:r>
               <a:rPr lang="en-US" sz="1500">
                 <a:solidFill>
-                  <a:srgbClr val="49495A"/>
+                  <a:srgbClr val="C4B8F5"/>
                 </a:solidFill>
                 <a:latin typeface="Open Sans"/>
                 <a:ea typeface="Open Sans"/>
@@ -7926,11 +8285,11 @@
             </a:avLst>
           </a:prstGeom>
           <a:solidFill>
-            <a:srgbClr val="FBFAFF"/>
+            <a:srgbClr val="14142E"/>
           </a:solidFill>
           <a:ln w="15240">
             <a:solidFill>
-              <a:srgbClr val="D0CED9"/>
+              <a:srgbClr val="1A1A2E"/>
             </a:solidFill>
             <a:prstDash val="solid"/>
           </a:ln>
@@ -7989,7 +8348,7 @@
             <a:r>
               <a:rPr lang="en-US" sz="1800" b="1">
                 <a:solidFill>
-                  <a:srgbClr val="49495A"/>
+                  <a:srgbClr val="C4B8F5"/>
                 </a:solidFill>
                 <a:latin typeface="Libre Baskerville"/>
                 <a:ea typeface="Libre Baskerville"/>
@@ -8032,7 +8391,7 @@
             <a:r>
               <a:rPr lang="en-US" sz="1500">
                 <a:solidFill>
-                  <a:srgbClr val="49495A"/>
+                  <a:srgbClr val="C4B8F5"/>
                 </a:solidFill>
                 <a:latin typeface="Open Sans"/>
                 <a:ea typeface="Open Sans"/>
@@ -8061,7 +8420,7 @@
             </a:avLst>
           </a:prstGeom>
           <a:solidFill>
-            <a:srgbClr val="B6D6FC"/>
+            <a:srgbClr val="2E3E5C"/>
           </a:solidFill>
           <a:ln/>
         </p:spPr>
@@ -8119,7 +8478,7 @@
             <a:r>
               <a:rPr lang="en-US" sz="1400">
                 <a:solidFill>
-                  <a:srgbClr val="000000"/>
+                  <a:srgbClr val="F2EEFF"/>
                 </a:solidFill>
                 <a:latin typeface="Open Sans"/>
                 <a:ea typeface="Open Sans"/>
@@ -8130,7 +8489,7 @@
             <a:r>
               <a:rPr lang="en-US" sz="1400" b="1">
                 <a:solidFill>
-                  <a:srgbClr val="000000"/>
+                  <a:srgbClr val="F2EEFF"/>
                 </a:solidFill>
                 <a:latin typeface="Open Sans"/>
                 <a:ea typeface="Open Sans"/>
@@ -8141,7 +8500,7 @@
             <a:r>
               <a:rPr lang="en-US" sz="1400">
                 <a:solidFill>
-                  <a:srgbClr val="000000"/>
+                  <a:srgbClr val="F2EEFF"/>
                 </a:solidFill>
                 <a:latin typeface="Open Sans"/>
                 <a:ea typeface="Open Sans"/>
@@ -8168,7 +8527,7 @@
             <a:avLst/>
           </a:prstGeom>
           <a:solidFill>
-            <a:schemeClr val="bg1"/>
+            <a:srgbClr val="14142E"/>
           </a:solidFill>
           <a:ln w="12700" cap="flat" cmpd="sng" algn="ctr">
             <a:noFill/>
@@ -8240,7 +8599,7 @@
             <a:r>
               <a:rPr lang="en-US" sz="2000" b="1" u="none">
                 <a:solidFill>
-                  <a:srgbClr val="C00000"/>
+                  <a:srgbClr val="FF6B6B"/>
                 </a:solidFill>
                 <a:latin typeface="Libre Baskerville"/>
                 <a:ea typeface="Libre Baskerville"/>
@@ -8250,7 +8609,7 @@
             </a:r>
             <a:endParaRPr sz="2000" b="1" u="none">
               <a:solidFill>
-                <a:srgbClr val="C00000"/>
+                <a:srgbClr val="FF6B6B"/>
               </a:solidFill>
               <a:latin typeface="Libre Baskerville"/>
               <a:ea typeface="Libre Baskerville"/>
@@ -8268,7 +8627,7 @@
             <a:r>
               <a:rPr lang="en-US" sz="2000" b="1" u="none">
                 <a:solidFill>
-                  <a:srgbClr val="C00000"/>
+                  <a:srgbClr val="FF6B6B"/>
                 </a:solidFill>
                 <a:latin typeface="Libre Baskerville"/>
                 <a:ea typeface="Libre Baskerville"/>
@@ -8278,7 +8637,7 @@
             </a:r>
             <a:endParaRPr sz="2000" b="1" u="none">
               <a:solidFill>
-                <a:srgbClr val="C00000"/>
+                <a:srgbClr val="FF6B6B"/>
               </a:solidFill>
             </a:endParaRPr>
           </a:p>
@@ -8315,7 +8674,7 @@
             <a:r>
               <a:rPr lang="en-US" sz="1600" i="1">
                 <a:solidFill>
-                  <a:srgbClr val="49495A"/>
+                  <a:srgbClr val="C4B8F5"/>
                 </a:solidFill>
                 <a:latin typeface="Open Sans"/>
                 <a:ea typeface="Open Sans"/>
@@ -8349,7 +8708,7 @@
     <p:bg>
       <p:bgPr shadeToTitle="0">
         <a:solidFill>
-          <a:srgbClr val="F6F6FB"/>
+          <a:srgbClr val="0B0B14"/>
         </a:solidFill>
       </p:bgPr>
     </p:bg>
@@ -8395,7 +8754,7 @@
             <a:r>
               <a:rPr lang="en-US" sz="4200" b="1">
                 <a:solidFill>
-                  <a:srgbClr val="4F46E5"/>
+                  <a:srgbClr val="A7A0F8"/>
                 </a:solidFill>
                 <a:latin typeface="Open Sans"/>
                 <a:ea typeface="Open Sans"/>
@@ -8435,7 +8794,7 @@
             <a:r>
               <a:rPr lang="en-US" sz="2200" b="1">
                 <a:solidFill>
-                  <a:srgbClr val="1F1F2E"/>
+                  <a:srgbClr val="E7E0FF"/>
                 </a:solidFill>
                 <a:latin typeface="Open Sans"/>
                 <a:ea typeface="Open Sans"/>
@@ -8446,7 +8805,7 @@
             <a:r>
               <a:rPr lang="en-US" sz="2200" i="1">
                 <a:solidFill>
-                  <a:srgbClr val="49495A"/>
+                  <a:srgbClr val="C4B8F5"/>
                 </a:solidFill>
                 <a:latin typeface="Open Sans"/>
                 <a:ea typeface="Open Sans"/>
@@ -8473,7 +8832,7 @@
             <a:avLst/>
           </a:prstGeom>
           <a:solidFill>
-            <a:srgbClr val="C4B8F5">
+            <a:srgbClr val="3B337A">
               <a:alpha val="50000"/>
             </a:srgbClr>
           </a:solidFill>
@@ -8497,11 +8856,11 @@
             </a:avLst>
           </a:prstGeom>
           <a:solidFill>
-            <a:srgbClr val="4F46E5"/>
+            <a:srgbClr val="635AE8"/>
           </a:solidFill>
           <a:ln w="12700">
             <a:solidFill>
-              <a:srgbClr val="4F46E5"/>
+              <a:srgbClr val="635AE8"/>
             </a:solidFill>
             <a:prstDash val="solid"/>
           </a:ln>
@@ -8583,11 +8942,11 @@
             <a:avLst/>
           </a:prstGeom>
           <a:solidFill>
-            <a:srgbClr val="FFFFFF"/>
+            <a:srgbClr val="14142E"/>
           </a:solidFill>
           <a:ln w="12700">
             <a:solidFill>
-              <a:srgbClr val="FFFFFF"/>
+              <a:srgbClr val="14142E"/>
             </a:solidFill>
             <a:prstDash val="solid"/>
           </a:ln>
@@ -8610,11 +8969,11 @@
             </a:avLst>
           </a:prstGeom>
           <a:solidFill>
-            <a:srgbClr val="FFFFFF"/>
+            <a:srgbClr val="14142E"/>
           </a:solidFill>
           <a:ln w="25400">
             <a:solidFill>
-              <a:srgbClr val="C4B8F5"/>
+              <a:srgbClr val="3B337A"/>
             </a:solidFill>
             <a:prstDash val="solid"/>
           </a:ln>
@@ -8644,11 +9003,11 @@
             <a:avLst/>
           </a:prstGeom>
           <a:solidFill>
-            <a:srgbClr val="4F46E5"/>
+            <a:srgbClr val="635AE8"/>
           </a:solidFill>
           <a:ln w="12700">
             <a:solidFill>
-              <a:srgbClr val="4F46E5"/>
+              <a:srgbClr val="635AE8"/>
             </a:solidFill>
             <a:prstDash val="solid"/>
           </a:ln>
@@ -8682,7 +9041,7 @@
             <a:r>
               <a:rPr lang="en-US" sz="2000" b="1">
                 <a:solidFill>
-                  <a:srgbClr val="1F1F2E"/>
+                  <a:srgbClr val="E7E0FF"/>
                 </a:solidFill>
                 <a:latin typeface="Open Sans"/>
                 <a:ea typeface="Open Sans"/>
@@ -8693,7 +9052,7 @@
             <a:br>
               <a:rPr lang="en-US" sz="1800" b="1">
                 <a:solidFill>
-                  <a:srgbClr val="1F1F2E"/>
+                  <a:srgbClr val="E7E0FF"/>
                 </a:solidFill>
                 <a:latin typeface="Open Sans"/>
                 <a:ea typeface="Open Sans"/>
@@ -8703,7 +9062,7 @@
             <a:r>
               <a:rPr lang="en-US" sz="1600">
                 <a:solidFill>
-                  <a:srgbClr val="49495A"/>
+                  <a:srgbClr val="C4B8F5"/>
                 </a:solidFill>
                 <a:latin typeface="Open Sans"/>
                 <a:ea typeface="Open Sans"/>
@@ -8732,7 +9091,7 @@
           <a:noFill/>
           <a:ln w="25400">
             <a:solidFill>
-              <a:srgbClr val="4F46E5"/>
+              <a:srgbClr val="635AE8"/>
             </a:solidFill>
             <a:prstDash val="solid"/>
             <a:tailEnd type="triangle"/>
@@ -8756,7 +9115,7 @@
           <a:noFill/>
           <a:ln w="25400">
             <a:solidFill>
-              <a:srgbClr val="7B6FE8"/>
+              <a:srgbClr val="8F88F0"/>
             </a:solidFill>
             <a:prstDash val="dash"/>
             <a:tailEnd type="triangle"/>
@@ -8791,7 +9150,7 @@
             <a:r>
               <a:rPr lang="en-US" sz="1300" b="1" i="1">
                 <a:solidFill>
-                  <a:srgbClr val="4F46E5"/>
+                  <a:srgbClr val="A7A0F8"/>
                 </a:solidFill>
                 <a:latin typeface="Open Sans"/>
                 <a:ea typeface="Open Sans"/>
@@ -8820,11 +9179,11 @@
             </a:avLst>
           </a:prstGeom>
           <a:solidFill>
-            <a:srgbClr val="FFFFFF"/>
+            <a:srgbClr val="14142E"/>
           </a:solidFill>
           <a:ln w="25400">
             <a:solidFill>
-              <a:srgbClr val="C4B8F5"/>
+              <a:srgbClr val="3B337A"/>
             </a:solidFill>
             <a:prstDash val="solid"/>
           </a:ln>
@@ -8854,11 +9213,11 @@
             <a:avLst/>
           </a:prstGeom>
           <a:solidFill>
-            <a:srgbClr val="4F46E5"/>
+            <a:srgbClr val="635AE8"/>
           </a:solidFill>
           <a:ln w="12700">
             <a:solidFill>
-              <a:srgbClr val="4F46E5"/>
+              <a:srgbClr val="635AE8"/>
             </a:solidFill>
             <a:prstDash val="solid"/>
           </a:ln>
@@ -8892,7 +9251,7 @@
             <a:r>
               <a:rPr lang="en-US" sz="2000" b="1">
                 <a:solidFill>
-                  <a:srgbClr val="1F1F2E"/>
+                  <a:srgbClr val="E7E0FF"/>
                 </a:solidFill>
                 <a:latin typeface="Open Sans"/>
                 <a:ea typeface="Open Sans"/>
@@ -8903,7 +9262,7 @@
             <a:br>
               <a:rPr lang="en-US" sz="1800" b="1">
                 <a:solidFill>
-                  <a:srgbClr val="1F1F2E"/>
+                  <a:srgbClr val="E7E0FF"/>
                 </a:solidFill>
                 <a:latin typeface="Open Sans"/>
                 <a:ea typeface="Open Sans"/>
@@ -8913,7 +9272,7 @@
             <a:r>
               <a:rPr lang="en-US" sz="1600">
                 <a:solidFill>
-                  <a:srgbClr val="49495A"/>
+                  <a:srgbClr val="C4B8F5"/>
                 </a:solidFill>
                 <a:latin typeface="Open Sans"/>
                 <a:ea typeface="Open Sans"/>
@@ -8942,7 +9301,7 @@
           <a:noFill/>
           <a:ln w="25400">
             <a:solidFill>
-              <a:srgbClr val="4F46E5"/>
+              <a:srgbClr val="635AE8"/>
             </a:solidFill>
             <a:prstDash val="solid"/>
             <a:tailEnd type="triangle"/>
@@ -8966,7 +9325,7 @@
           <a:noFill/>
           <a:ln w="25400">
             <a:solidFill>
-              <a:srgbClr val="7B6FE8"/>
+              <a:srgbClr val="8F88F0"/>
             </a:solidFill>
             <a:prstDash val="dash"/>
             <a:tailEnd type="triangle"/>
@@ -9001,7 +9360,7 @@
             <a:r>
               <a:rPr lang="en-US" sz="1300" b="1" i="1">
                 <a:solidFill>
-                  <a:srgbClr val="4F46E5"/>
+                  <a:srgbClr val="A7A0F8"/>
                 </a:solidFill>
                 <a:latin typeface="Open Sans"/>
                 <a:ea typeface="Open Sans"/>
@@ -9030,11 +9389,11 @@
             </a:avLst>
           </a:prstGeom>
           <a:solidFill>
-            <a:srgbClr val="FFFFFF"/>
+            <a:srgbClr val="14142E"/>
           </a:solidFill>
           <a:ln w="25400">
             <a:solidFill>
-              <a:srgbClr val="C4B8F5"/>
+              <a:srgbClr val="3B337A"/>
             </a:solidFill>
             <a:prstDash val="solid"/>
           </a:ln>
@@ -9055,11 +9414,11 @@
             <a:avLst/>
           </a:prstGeom>
           <a:solidFill>
-            <a:srgbClr val="4F46E5"/>
+            <a:srgbClr val="635AE8"/>
           </a:solidFill>
           <a:ln w="12700">
             <a:solidFill>
-              <a:srgbClr val="4F46E5"/>
+              <a:srgbClr val="635AE8"/>
             </a:solidFill>
             <a:prstDash val="solid"/>
           </a:ln>
@@ -9093,7 +9452,7 @@
             <a:r>
               <a:rPr lang="en-US" sz="2000" b="1">
                 <a:solidFill>
-                  <a:srgbClr val="1F1F2E"/>
+                  <a:srgbClr val="E7E0FF"/>
                 </a:solidFill>
                 <a:latin typeface="Open Sans"/>
                 <a:ea typeface="Open Sans"/>
@@ -9104,7 +9463,7 @@
             <a:br>
               <a:rPr lang="en-US" sz="2000" b="1">
                 <a:solidFill>
-                  <a:srgbClr val="1F1F2E"/>
+                  <a:srgbClr val="E7E0FF"/>
                 </a:solidFill>
                 <a:latin typeface="Open Sans"/>
                 <a:ea typeface="Open Sans"/>
@@ -9114,7 +9473,7 @@
             <a:r>
               <a:rPr lang="en-US" sz="1600">
                 <a:solidFill>
-                  <a:srgbClr val="49495A"/>
+                  <a:srgbClr val="C4B8F5"/>
                 </a:solidFill>
                 <a:latin typeface="Open Sans"/>
                 <a:ea typeface="Open Sans"/>
@@ -9143,7 +9502,7 @@
           <a:noFill/>
           <a:ln w="25400">
             <a:solidFill>
-              <a:srgbClr val="4F46E5"/>
+              <a:srgbClr val="635AE8"/>
             </a:solidFill>
             <a:prstDash val="solid"/>
             <a:tailEnd type="triangle"/>
@@ -9167,7 +9526,7 @@
           <a:noFill/>
           <a:ln w="25400">
             <a:solidFill>
-              <a:srgbClr val="7B6FE8"/>
+              <a:srgbClr val="8F88F0"/>
             </a:solidFill>
             <a:prstDash val="dash"/>
             <a:tailEnd type="triangle"/>
@@ -9202,7 +9561,7 @@
             <a:r>
               <a:rPr lang="en-US" sz="1300" b="1" i="1">
                 <a:solidFill>
-                  <a:srgbClr val="4F46E5"/>
+                  <a:srgbClr val="A7A0F8"/>
                 </a:solidFill>
                 <a:latin typeface="Open Sans"/>
                 <a:ea typeface="Open Sans"/>
@@ -9231,11 +9590,11 @@
             </a:avLst>
           </a:prstGeom>
           <a:solidFill>
-            <a:srgbClr val="FFFFFF"/>
+            <a:srgbClr val="14142E"/>
           </a:solidFill>
           <a:ln w="25400">
             <a:solidFill>
-              <a:srgbClr val="C4B8F5"/>
+              <a:srgbClr val="3B337A"/>
             </a:solidFill>
             <a:prstDash val="solid"/>
           </a:ln>
@@ -9265,11 +9624,11 @@
             <a:avLst/>
           </a:prstGeom>
           <a:solidFill>
-            <a:srgbClr val="4F46E5"/>
+            <a:srgbClr val="635AE8"/>
           </a:solidFill>
           <a:ln w="12700">
             <a:solidFill>
-              <a:srgbClr val="4F46E5"/>
+              <a:srgbClr val="635AE8"/>
             </a:solidFill>
             <a:prstDash val="solid"/>
           </a:ln>
@@ -9303,7 +9662,7 @@
             <a:r>
               <a:rPr lang="en-US" sz="2000" b="1">
                 <a:solidFill>
-                  <a:srgbClr val="1F1F2E"/>
+                  <a:srgbClr val="E7E0FF"/>
                 </a:solidFill>
                 <a:latin typeface="Open Sans"/>
                 <a:ea typeface="Open Sans"/>
@@ -9314,7 +9673,7 @@
             <a:br>
               <a:rPr lang="en-US" sz="2000" b="1">
                 <a:solidFill>
-                  <a:srgbClr val="1F1F2E"/>
+                  <a:srgbClr val="E7E0FF"/>
                 </a:solidFill>
                 <a:latin typeface="Open Sans"/>
                 <a:ea typeface="Open Sans"/>
@@ -9324,7 +9683,7 @@
             <a:r>
               <a:rPr lang="en-US" sz="1600">
                 <a:solidFill>
-                  <a:srgbClr val="49495A"/>
+                  <a:srgbClr val="C4B8F5"/>
                 </a:solidFill>
                 <a:latin typeface="Open Sans"/>
                 <a:ea typeface="Open Sans"/>
@@ -9353,7 +9712,7 @@
           <a:noFill/>
           <a:ln w="25400">
             <a:solidFill>
-              <a:srgbClr val="4F46E5"/>
+              <a:srgbClr val="635AE8"/>
             </a:solidFill>
             <a:prstDash val="solid"/>
             <a:tailEnd type="triangle"/>
@@ -9377,7 +9736,7 @@
           <a:noFill/>
           <a:ln w="25400">
             <a:solidFill>
-              <a:srgbClr val="7B6FE8"/>
+              <a:srgbClr val="8F88F0"/>
             </a:solidFill>
             <a:prstDash val="dash"/>
             <a:tailEnd type="triangle"/>
@@ -9412,7 +9771,7 @@
             <a:r>
               <a:rPr lang="en-US" sz="1300" b="1" i="1">
                 <a:solidFill>
-                  <a:srgbClr val="4F46E5"/>
+                  <a:srgbClr val="A7A0F8"/>
                 </a:solidFill>
                 <a:latin typeface="Open Sans"/>
                 <a:ea typeface="Open Sans"/>
@@ -9441,11 +9800,11 @@
             </a:avLst>
           </a:prstGeom>
           <a:solidFill>
-            <a:srgbClr val="FFFFFF"/>
+            <a:srgbClr val="14142E"/>
           </a:solidFill>
           <a:ln w="12700">
             <a:solidFill>
-              <a:srgbClr val="C4B8F5"/>
+              <a:srgbClr val="3B337A"/>
             </a:solidFill>
             <a:prstDash val="solid"/>
           </a:ln>
@@ -9468,7 +9827,7 @@
           <a:noFill/>
           <a:ln w="25400">
             <a:solidFill>
-              <a:srgbClr val="4F46E5"/>
+              <a:srgbClr val="635AE8"/>
             </a:solidFill>
             <a:prstDash val="solid"/>
             <a:tailEnd type="triangle"/>
@@ -9503,7 +9862,7 @@
             <a:r>
               <a:rPr lang="en-US" sz="1500">
                 <a:solidFill>
-                  <a:srgbClr val="1F1F2E"/>
+                  <a:srgbClr val="E7E0FF"/>
                 </a:solidFill>
                 <a:latin typeface="Open Sans"/>
                 <a:ea typeface="Open Sans"/>
@@ -9532,7 +9891,7 @@
           <a:noFill/>
           <a:ln w="25400">
             <a:solidFill>
-              <a:srgbClr val="7B6FE8"/>
+              <a:srgbClr val="8F88F0"/>
             </a:solidFill>
             <a:prstDash val="dash"/>
             <a:tailEnd type="triangle"/>
@@ -9567,7 +9926,7 @@
             <a:r>
               <a:rPr lang="en-US" sz="1500">
                 <a:solidFill>
-                  <a:srgbClr val="1F1F2E"/>
+                  <a:srgbClr val="E7E0FF"/>
                 </a:solidFill>
                 <a:latin typeface="Open Sans"/>
                 <a:ea typeface="Open Sans"/>
@@ -9594,7 +9953,7 @@
             <a:avLst/>
           </a:prstGeom>
           <a:solidFill>
-            <a:schemeClr val="bg1"/>
+            <a:srgbClr val="14142E"/>
           </a:solidFill>
           <a:ln w="12700" cap="flat" cmpd="sng" algn="ctr">
             <a:noFill/>
@@ -9699,7 +10058,7 @@
             <a:r>
               <a:rPr lang="en-US" sz="4200" b="1">
                 <a:solidFill>
-                  <a:srgbClr val="403CCF"/>
+                  <a:srgbClr val="9A93F5"/>
                 </a:solidFill>
                 <a:latin typeface="Libre Baskerville"/>
                 <a:ea typeface="Libre Baskerville"/>
@@ -9742,7 +10101,7 @@
             <a:r>
               <a:rPr lang="en-US" sz="2200">
                 <a:solidFill>
-                  <a:srgbClr val="403CCF"/>
+                  <a:srgbClr val="9A93F5"/>
                 </a:solidFill>
                 <a:latin typeface="Libre Baskerville"/>
                 <a:ea typeface="Libre Baskerville"/>
@@ -9771,7 +10130,7 @@
             </a:avLst>
           </a:prstGeom>
           <a:solidFill>
-            <a:srgbClr val="EAE8F3"/>
+            <a:srgbClr val="1A1A2E"/>
           </a:solidFill>
           <a:ln/>
         </p:spPr>
@@ -9857,7 +10216,7 @@
             <a:r>
               <a:rPr lang="en-US" sz="1900" i="1" u="sng">
                 <a:solidFill>
-                  <a:srgbClr val="49495A"/>
+                  <a:srgbClr val="C4B8F5"/>
                 </a:solidFill>
                 <a:latin typeface="Libre Baskerville"/>
                 <a:ea typeface="Libre Baskerville"/>
@@ -9900,7 +10259,7 @@
             <a:r>
               <a:rPr lang="en-US" sz="1600">
                 <a:solidFill>
-                  <a:srgbClr val="49495A"/>
+                  <a:srgbClr val="C4B8F5"/>
                 </a:solidFill>
                 <a:latin typeface="Open Sans"/>
                 <a:ea typeface="Open Sans"/>
@@ -9929,7 +10288,7 @@
             </a:avLst>
           </a:prstGeom>
           <a:solidFill>
-            <a:srgbClr val="EAE8F3"/>
+            <a:srgbClr val="1A1A2E"/>
           </a:solidFill>
           <a:ln/>
         </p:spPr>
@@ -10015,7 +10374,7 @@
             <a:r>
               <a:rPr lang="en-US" sz="1900" i="1" u="sng">
                 <a:solidFill>
-                  <a:srgbClr val="49495A"/>
+                  <a:srgbClr val="C4B8F5"/>
                 </a:solidFill>
                 <a:latin typeface="Libre Baskerville"/>
                 <a:ea typeface="Libre Baskerville"/>
@@ -10058,7 +10417,7 @@
             <a:r>
               <a:rPr lang="en-US" sz="1600">
                 <a:solidFill>
-                  <a:srgbClr val="49495A"/>
+                  <a:srgbClr val="C4B8F5"/>
                 </a:solidFill>
                 <a:latin typeface="Open Sans"/>
                 <a:ea typeface="Open Sans"/>
@@ -10087,7 +10446,7 @@
             </a:avLst>
           </a:prstGeom>
           <a:solidFill>
-            <a:srgbClr val="EAE8F3"/>
+            <a:srgbClr val="1A1A2E"/>
           </a:solidFill>
           <a:ln/>
         </p:spPr>
@@ -10173,7 +10532,7 @@
             <a:r>
               <a:rPr lang="en-US" sz="1900" i="1" u="sng">
                 <a:solidFill>
-                  <a:srgbClr val="49495A"/>
+                  <a:srgbClr val="C4B8F5"/>
                 </a:solidFill>
                 <a:latin typeface="Libre Baskerville"/>
                 <a:ea typeface="Libre Baskerville"/>
@@ -10216,7 +10575,7 @@
             <a:r>
               <a:rPr lang="en-US" sz="1600">
                 <a:solidFill>
-                  <a:srgbClr val="49495A"/>
+                  <a:srgbClr val="C4B8F5"/>
                 </a:solidFill>
                 <a:latin typeface="Open Sans"/>
                 <a:ea typeface="Open Sans"/>
@@ -10245,7 +10604,7 @@
             </a:avLst>
           </a:prstGeom>
           <a:solidFill>
-            <a:srgbClr val="EAE8F3"/>
+            <a:srgbClr val="1A1A2E"/>
           </a:solidFill>
           <a:ln/>
         </p:spPr>
@@ -10331,7 +10690,7 @@
             <a:r>
               <a:rPr lang="en-US" sz="1900" i="1" u="sng">
                 <a:solidFill>
-                  <a:srgbClr val="49495A"/>
+                  <a:srgbClr val="C4B8F5"/>
                 </a:solidFill>
                 <a:latin typeface="Libre Baskerville"/>
                 <a:ea typeface="Libre Baskerville"/>
@@ -10374,7 +10733,7 @@
             <a:r>
               <a:rPr lang="en-US" sz="1600">
                 <a:solidFill>
-                  <a:srgbClr val="49495A"/>
+                  <a:srgbClr val="C4B8F5"/>
                 </a:solidFill>
                 <a:latin typeface="Open Sans"/>
                 <a:ea typeface="Open Sans"/>
@@ -10417,7 +10776,7 @@
             <a:r>
               <a:rPr lang="en-US" sz="2200" b="1">
                 <a:solidFill>
-                  <a:srgbClr val="403CCF"/>
+                  <a:srgbClr val="9A93F5"/>
                 </a:solidFill>
                 <a:latin typeface="Libre Baskerville"/>
                 <a:ea typeface="Libre Baskerville"/>
@@ -10460,7 +10819,7 @@
             <a:r>
               <a:rPr lang="en-US" sz="1600">
                 <a:solidFill>
-                  <a:srgbClr val="49495A"/>
+                  <a:srgbClr val="C4B8F5"/>
                 </a:solidFill>
                 <a:latin typeface="Open Sans"/>
                 <a:ea typeface="Open Sans"/>
@@ -10503,7 +10862,7 @@
             <a:r>
               <a:rPr lang="en-US" sz="2200" b="1">
                 <a:solidFill>
-                  <a:srgbClr val="403CCF"/>
+                  <a:srgbClr val="9A93F5"/>
                 </a:solidFill>
                 <a:latin typeface="Libre Baskerville"/>
                 <a:ea typeface="Libre Baskerville"/>
@@ -10546,7 +10905,7 @@
             <a:r>
               <a:rPr lang="en-US" sz="1600">
                 <a:solidFill>
-                  <a:srgbClr val="49495A"/>
+                  <a:srgbClr val="C4B8F5"/>
                 </a:solidFill>
                 <a:latin typeface="Open Sans"/>
                 <a:ea typeface="Open Sans"/>
@@ -10589,7 +10948,7 @@
             <a:r>
               <a:rPr lang="en-US" sz="1600">
                 <a:solidFill>
-                  <a:srgbClr val="49495A"/>
+                  <a:srgbClr val="C4B8F5"/>
                 </a:solidFill>
                 <a:latin typeface="Open Sans"/>
                 <a:ea typeface="Open Sans"/>
@@ -10616,7 +10975,7 @@
             <a:avLst/>
           </a:prstGeom>
           <a:solidFill>
-            <a:srgbClr val="403CCF"/>
+            <a:srgbClr val="5A52DC"/>
           </a:solidFill>
           <a:ln/>
         </p:spPr>
@@ -10636,7 +10995,7 @@
             <a:avLst/>
           </a:prstGeom>
           <a:solidFill>
-            <a:schemeClr val="bg1"/>
+            <a:srgbClr val="14142E"/>
           </a:solidFill>
           <a:ln w="12700" cap="flat" cmpd="sng" algn="ctr">
             <a:noFill/>
@@ -10741,7 +11100,7 @@
             <a:r>
               <a:rPr lang="en-US" sz="4200" b="1">
                 <a:solidFill>
-                  <a:srgbClr val="403CCF"/>
+                  <a:srgbClr val="9A93F5"/>
                 </a:solidFill>
                 <a:latin typeface="Libre Baskerville"/>
                 <a:ea typeface="Libre Baskerville"/>
@@ -10772,7 +11131,7 @@
           <a:noFill/>
           <a:ln w="7620">
             <a:solidFill>
-              <a:srgbClr val="000000">
+              <a:srgbClr val="0B0B14">
                 <a:alpha val="7999"/>
               </a:srgbClr>
             </a:solidFill>
@@ -10811,7 +11170,7 @@
             <a:r>
               <a:rPr lang="en-US" sz="1600" b="1">
                 <a:solidFill>
-                  <a:srgbClr val="49495A"/>
+                  <a:srgbClr val="C4B8F5"/>
                 </a:solidFill>
                 <a:latin typeface="Open Sans"/>
                 <a:ea typeface="Open Sans"/>
@@ -10854,7 +11213,7 @@
             <a:r>
               <a:rPr lang="en-US" sz="1600" b="1">
                 <a:solidFill>
-                  <a:srgbClr val="49495A"/>
+                  <a:srgbClr val="C4B8F5"/>
                 </a:solidFill>
                 <a:latin typeface="Open Sans"/>
                 <a:ea typeface="Open Sans"/>
@@ -10897,7 +11256,7 @@
             <a:r>
               <a:rPr lang="en-US" sz="1600" b="1">
                 <a:solidFill>
-                  <a:srgbClr val="49495A"/>
+                  <a:srgbClr val="C4B8F5"/>
                 </a:solidFill>
                 <a:latin typeface="Open Sans"/>
                 <a:ea typeface="Open Sans"/>
@@ -10940,7 +11299,7 @@
             <a:r>
               <a:rPr lang="en-US" sz="1600">
                 <a:solidFill>
-                  <a:srgbClr val="49495A"/>
+                  <a:srgbClr val="C4B8F5"/>
                 </a:solidFill>
                 <a:latin typeface="Open Sans"/>
                 <a:ea typeface="Open Sans"/>
@@ -10983,7 +11342,7 @@
             <a:r>
               <a:rPr lang="en-US" sz="1600">
                 <a:solidFill>
-                  <a:srgbClr val="49495A"/>
+                  <a:srgbClr val="C4B8F5"/>
                 </a:solidFill>
                 <a:latin typeface="Open Sans"/>
                 <a:ea typeface="Open Sans"/>
@@ -11026,7 +11385,7 @@
             <a:r>
               <a:rPr lang="en-US" sz="1600">
                 <a:solidFill>
-                  <a:srgbClr val="49495A"/>
+                  <a:srgbClr val="C4B8F5"/>
                 </a:solidFill>
                 <a:latin typeface="Open Sans"/>
                 <a:ea typeface="Open Sans"/>
@@ -11069,7 +11428,7 @@
             <a:r>
               <a:rPr lang="en-US" sz="1600">
                 <a:solidFill>
-                  <a:srgbClr val="49495A"/>
+                  <a:srgbClr val="C4B8F5"/>
                 </a:solidFill>
                 <a:latin typeface="Open Sans"/>
                 <a:ea typeface="Open Sans"/>
@@ -11112,7 +11471,7 @@
             <a:r>
               <a:rPr lang="en-US" sz="1600">
                 <a:solidFill>
-                  <a:srgbClr val="49495A"/>
+                  <a:srgbClr val="C4B8F5"/>
                 </a:solidFill>
                 <a:latin typeface="Open Sans"/>
                 <a:ea typeface="Open Sans"/>
@@ -11155,7 +11514,7 @@
             <a:r>
               <a:rPr lang="en-US" sz="1600">
                 <a:solidFill>
-                  <a:srgbClr val="49495A"/>
+                  <a:srgbClr val="C4B8F5"/>
                 </a:solidFill>
                 <a:latin typeface="Open Sans"/>
                 <a:ea typeface="Open Sans"/>
@@ -11198,7 +11557,7 @@
             <a:r>
               <a:rPr lang="en-US" sz="1600">
                 <a:solidFill>
-                  <a:srgbClr val="49495A"/>
+                  <a:srgbClr val="C4B8F5"/>
                 </a:solidFill>
                 <a:latin typeface="Open Sans"/>
                 <a:ea typeface="Open Sans"/>
@@ -11241,7 +11600,7 @@
             <a:r>
               <a:rPr lang="en-US" sz="1600">
                 <a:solidFill>
-                  <a:srgbClr val="49495A"/>
+                  <a:srgbClr val="C4B8F5"/>
                 </a:solidFill>
                 <a:latin typeface="Open Sans"/>
                 <a:ea typeface="Open Sans"/>
@@ -11284,7 +11643,7 @@
             <a:r>
               <a:rPr lang="en-US" sz="1600">
                 <a:solidFill>
-                  <a:srgbClr val="49495A"/>
+                  <a:srgbClr val="C4B8F5"/>
                 </a:solidFill>
                 <a:latin typeface="Open Sans"/>
                 <a:ea typeface="Open Sans"/>
@@ -11327,7 +11686,7 @@
             <a:r>
               <a:rPr lang="en-US" sz="1600">
                 <a:solidFill>
-                  <a:srgbClr val="49495A"/>
+                  <a:srgbClr val="C4B8F5"/>
                 </a:solidFill>
                 <a:latin typeface="Open Sans"/>
                 <a:ea typeface="Open Sans"/>
@@ -11370,7 +11729,7 @@
             <a:r>
               <a:rPr lang="en-US" sz="1600">
                 <a:solidFill>
-                  <a:srgbClr val="49495A"/>
+                  <a:srgbClr val="C4B8F5"/>
                 </a:solidFill>
                 <a:latin typeface="Open Sans"/>
                 <a:ea typeface="Open Sans"/>
@@ -11413,7 +11772,7 @@
             <a:r>
               <a:rPr lang="en-US" sz="1600">
                 <a:solidFill>
-                  <a:srgbClr val="49495A"/>
+                  <a:srgbClr val="C4B8F5"/>
                 </a:solidFill>
                 <a:latin typeface="Open Sans"/>
                 <a:ea typeface="Open Sans"/>
@@ -11456,7 +11815,7 @@
             <a:r>
               <a:rPr lang="en-US" sz="1600">
                 <a:solidFill>
-                  <a:srgbClr val="49495A"/>
+                  <a:srgbClr val="C4B8F5"/>
                 </a:solidFill>
                 <a:latin typeface="Open Sans"/>
                 <a:ea typeface="Open Sans"/>
@@ -11499,7 +11858,7 @@
             <a:r>
               <a:rPr lang="en-US" sz="1600">
                 <a:solidFill>
-                  <a:srgbClr val="49495A"/>
+                  <a:srgbClr val="C4B8F5"/>
                 </a:solidFill>
                 <a:latin typeface="Open Sans"/>
                 <a:ea typeface="Open Sans"/>
@@ -11542,7 +11901,7 @@
             <a:r>
               <a:rPr lang="en-US" sz="1600">
                 <a:solidFill>
-                  <a:srgbClr val="49495A"/>
+                  <a:srgbClr val="C4B8F5"/>
                 </a:solidFill>
                 <a:latin typeface="Open Sans"/>
                 <a:ea typeface="Open Sans"/>
@@ -11585,7 +11944,7 @@
             <a:r>
               <a:rPr lang="en-US" sz="1600">
                 <a:solidFill>
-                  <a:srgbClr val="49495A"/>
+                  <a:srgbClr val="C4B8F5"/>
                 </a:solidFill>
                 <a:latin typeface="Open Sans"/>
                 <a:ea typeface="Open Sans"/>
@@ -11628,7 +11987,7 @@
             <a:r>
               <a:rPr lang="en-US" sz="1600">
                 <a:solidFill>
-                  <a:srgbClr val="49495A"/>
+                  <a:srgbClr val="C4B8F5"/>
                 </a:solidFill>
                 <a:latin typeface="Open Sans"/>
                 <a:ea typeface="Open Sans"/>
@@ -11671,7 +12030,7 @@
             <a:r>
               <a:rPr lang="en-US" sz="1600">
                 <a:solidFill>
-                  <a:srgbClr val="49495A"/>
+                  <a:srgbClr val="C4B8F5"/>
                 </a:solidFill>
                 <a:latin typeface="Open Sans"/>
                 <a:ea typeface="Open Sans"/>
@@ -11714,7 +12073,7 @@
             <a:r>
               <a:rPr lang="en-US" sz="1600">
                 <a:solidFill>
-                  <a:srgbClr val="49495A"/>
+                  <a:srgbClr val="C4B8F5"/>
                 </a:solidFill>
                 <a:latin typeface="Open Sans"/>
                 <a:ea typeface="Open Sans"/>
@@ -11757,7 +12116,7 @@
             <a:r>
               <a:rPr lang="en-US" sz="1600">
                 <a:solidFill>
-                  <a:srgbClr val="49495A"/>
+                  <a:srgbClr val="C4B8F5"/>
                 </a:solidFill>
                 <a:latin typeface="Open Sans"/>
                 <a:ea typeface="Open Sans"/>
@@ -11800,7 +12159,7 @@
             <a:r>
               <a:rPr lang="en-US" sz="1600">
                 <a:solidFill>
-                  <a:srgbClr val="49495A"/>
+                  <a:srgbClr val="C4B8F5"/>
                 </a:solidFill>
                 <a:latin typeface="Open Sans"/>
                 <a:ea typeface="Open Sans"/>
@@ -11843,7 +12202,7 @@
             <a:r>
               <a:rPr lang="en-US" sz="1600">
                 <a:solidFill>
-                  <a:srgbClr val="49495A"/>
+                  <a:srgbClr val="C4B8F5"/>
                 </a:solidFill>
                 <a:latin typeface="Open Sans"/>
                 <a:ea typeface="Open Sans"/>
@@ -11886,7 +12245,7 @@
             <a:r>
               <a:rPr lang="en-US" sz="1600">
                 <a:solidFill>
-                  <a:srgbClr val="49495A"/>
+                  <a:srgbClr val="C4B8F5"/>
                 </a:solidFill>
                 <a:latin typeface="Open Sans"/>
                 <a:ea typeface="Open Sans"/>
@@ -11929,7 +12288,7 @@
             <a:r>
               <a:rPr lang="en-US" sz="1600">
                 <a:solidFill>
-                  <a:srgbClr val="49495A"/>
+                  <a:srgbClr val="C4B8F5"/>
                 </a:solidFill>
                 <a:latin typeface="Open Sans"/>
                 <a:ea typeface="Open Sans"/>
@@ -11958,7 +12317,7 @@
             </a:avLst>
           </a:prstGeom>
           <a:solidFill>
-            <a:srgbClr val="EAE8F3"/>
+            <a:srgbClr val="1A1A2E"/>
           </a:solidFill>
           <a:ln/>
         </p:spPr>
@@ -11994,7 +12353,7 @@
             <a:r>
               <a:rPr lang="en-US" sz="1900">
                 <a:solidFill>
-                  <a:srgbClr val="49495A"/>
+                  <a:srgbClr val="C4B8F5"/>
                 </a:solidFill>
                 <a:latin typeface="Libre Baskerville"/>
                 <a:ea typeface="Libre Baskerville"/>
@@ -12037,7 +12396,7 @@
             <a:r>
               <a:rPr lang="en-US" sz="1500">
                 <a:solidFill>
-                  <a:srgbClr val="49495A"/>
+                  <a:srgbClr val="C4B8F5"/>
                 </a:solidFill>
                 <a:latin typeface="Open Sans"/>
                 <a:ea typeface="Open Sans"/>
@@ -12066,7 +12425,7 @@
             </a:avLst>
           </a:prstGeom>
           <a:solidFill>
-            <a:srgbClr val="EAE8F3"/>
+            <a:srgbClr val="1A1A2E"/>
           </a:solidFill>
           <a:ln/>
         </p:spPr>
@@ -12102,7 +12461,7 @@
             <a:r>
               <a:rPr lang="en-US" sz="1900">
                 <a:solidFill>
-                  <a:srgbClr val="49495A"/>
+                  <a:srgbClr val="C4B8F5"/>
                 </a:solidFill>
                 <a:latin typeface="Libre Baskerville"/>
                 <a:ea typeface="Libre Baskerville"/>
@@ -12145,7 +12504,7 @@
             <a:r>
               <a:rPr lang="en-US" sz="1500">
                 <a:solidFill>
-                  <a:srgbClr val="49495A"/>
+                  <a:srgbClr val="C4B8F5"/>
                 </a:solidFill>
                 <a:latin typeface="Open Sans"/>
                 <a:ea typeface="Open Sans"/>
@@ -12174,7 +12533,7 @@
             </a:avLst>
           </a:prstGeom>
           <a:solidFill>
-            <a:srgbClr val="EAE8F3"/>
+            <a:srgbClr val="1A1A2E"/>
           </a:solidFill>
           <a:ln/>
         </p:spPr>
@@ -12210,7 +12569,7 @@
             <a:r>
               <a:rPr lang="en-US" sz="1900">
                 <a:solidFill>
-                  <a:srgbClr val="49495A"/>
+                  <a:srgbClr val="C4B8F5"/>
                 </a:solidFill>
                 <a:latin typeface="Libre Baskerville"/>
                 <a:ea typeface="Libre Baskerville"/>
@@ -12253,7 +12612,7 @@
             <a:r>
               <a:rPr lang="en-US" sz="1500">
                 <a:solidFill>
-                  <a:srgbClr val="49495A"/>
+                  <a:srgbClr val="C4B8F5"/>
                 </a:solidFill>
                 <a:latin typeface="Open Sans"/>
                 <a:ea typeface="Open Sans"/>
@@ -12280,7 +12639,7 @@
             <a:avLst/>
           </a:prstGeom>
           <a:solidFill>
-            <a:schemeClr val="bg1"/>
+            <a:srgbClr val="14142E"/>
           </a:solidFill>
           <a:ln w="12700" cap="flat" cmpd="sng" algn="ctr">
             <a:noFill/>
@@ -12385,7 +12744,7 @@
             <a:r>
               <a:rPr lang="en-US" sz="4200" b="1">
                 <a:solidFill>
-                  <a:srgbClr val="403CCF"/>
+                  <a:srgbClr val="9A93F5"/>
                 </a:solidFill>
                 <a:latin typeface="Libre Baskerville"/>
                 <a:ea typeface="Libre Baskerville"/>
@@ -12428,7 +12787,7 @@
             <a:r>
               <a:rPr lang="en-US" sz="2400">
                 <a:solidFill>
-                  <a:srgbClr val="5955EB"/>
+                  <a:srgbClr val="ADA8F9"/>
                 </a:solidFill>
                 <a:latin typeface="Libre Baskerville"/>
                 <a:ea typeface="Libre Baskerville"/>
@@ -12439,7 +12798,7 @@
             <a:r>
               <a:rPr lang="en-US" sz="2400">
                 <a:solidFill>
-                  <a:srgbClr val="403CCF"/>
+                  <a:srgbClr val="9A93F5"/>
                 </a:solidFill>
                 <a:latin typeface="Libre Baskerville"/>
                 <a:ea typeface="Libre Baskerville"/>
@@ -12468,7 +12827,7 @@
             </a:avLst>
           </a:prstGeom>
           <a:solidFill>
-            <a:srgbClr val="EAE8F3"/>
+            <a:srgbClr val="1A1A2E"/>
           </a:solidFill>
           <a:ln/>
         </p:spPr>
@@ -12490,7 +12849,7 @@
             </a:avLst>
           </a:prstGeom>
           <a:solidFill>
-            <a:srgbClr val="EAE8F3"/>
+            <a:srgbClr val="1A1A2E"/>
           </a:solidFill>
           <a:ln/>
         </p:spPr>
@@ -12554,7 +12913,7 @@
             <a:r>
               <a:rPr lang="en-US" sz="2150">
                 <a:solidFill>
-                  <a:srgbClr val="49495A"/>
+                  <a:srgbClr val="C4B8F5"/>
                 </a:solidFill>
                 <a:latin typeface="Libre Baskerville"/>
                 <a:ea typeface="Libre Baskerville"/>
@@ -12597,7 +12956,7 @@
             <a:r>
               <a:rPr lang="en-US" sz="1700">
                 <a:solidFill>
-                  <a:srgbClr val="49495A"/>
+                  <a:srgbClr val="C4B8F5"/>
                 </a:solidFill>
                 <a:latin typeface="Open Sans"/>
                 <a:ea typeface="Open Sans"/>
@@ -12608,7 +12967,7 @@
             <a:r>
               <a:rPr lang="en-US" sz="1700">
                 <a:solidFill>
-                  <a:srgbClr val="49495A"/>
+                  <a:srgbClr val="C4B8F5"/>
                 </a:solidFill>
                 <a:highlight>
                   <a:srgbClr val="EEEDF2"/>
@@ -12622,7 +12981,7 @@
             <a:r>
               <a:rPr lang="en-US" sz="1700">
                 <a:solidFill>
-                  <a:srgbClr val="49495A"/>
+                  <a:srgbClr val="C4B8F5"/>
                 </a:solidFill>
                 <a:latin typeface="Open Sans"/>
                 <a:ea typeface="Open Sans"/>
@@ -12633,7 +12992,7 @@
             <a:r>
               <a:rPr lang="en-US" sz="1700" b="1">
                 <a:solidFill>
-                  <a:srgbClr val="49495A"/>
+                  <a:srgbClr val="C4B8F5"/>
                 </a:solidFill>
                 <a:latin typeface="Open Sans"/>
                 <a:ea typeface="Open Sans"/>
@@ -12644,7 +13003,7 @@
             <a:r>
               <a:rPr lang="en-US" sz="1700">
                 <a:solidFill>
-                  <a:srgbClr val="49495A"/>
+                  <a:srgbClr val="C4B8F5"/>
                 </a:solidFill>
                 <a:latin typeface="Open Sans"/>
                 <a:ea typeface="Open Sans"/>
@@ -12673,7 +13032,7 @@
             </a:avLst>
           </a:prstGeom>
           <a:solidFill>
-            <a:srgbClr val="EAE8F3"/>
+            <a:srgbClr val="1A1A2E"/>
           </a:solidFill>
           <a:ln/>
         </p:spPr>
@@ -12695,7 +13054,7 @@
             </a:avLst>
           </a:prstGeom>
           <a:solidFill>
-            <a:srgbClr val="EAE8F3"/>
+            <a:srgbClr val="1A1A2E"/>
           </a:solidFill>
           <a:ln/>
         </p:spPr>
@@ -12759,7 +13118,7 @@
             <a:r>
               <a:rPr lang="en-US" sz="2150">
                 <a:solidFill>
-                  <a:srgbClr val="49495A"/>
+                  <a:srgbClr val="C4B8F5"/>
                 </a:solidFill>
                 <a:latin typeface="Libre Baskerville"/>
                 <a:ea typeface="Libre Baskerville"/>
@@ -12802,7 +13161,7 @@
             <a:r>
               <a:rPr lang="en-US" sz="1700">
                 <a:solidFill>
-                  <a:srgbClr val="49495A"/>
+                  <a:srgbClr val="C4B8F5"/>
                 </a:solidFill>
                 <a:latin typeface="Open Sans"/>
                 <a:ea typeface="Open Sans"/>
@@ -12813,7 +13172,7 @@
             <a:r>
               <a:rPr lang="en-US" sz="1700" b="1">
                 <a:solidFill>
-                  <a:srgbClr val="49495A"/>
+                  <a:srgbClr val="C4B8F5"/>
                 </a:solidFill>
                 <a:latin typeface="Open Sans"/>
                 <a:ea typeface="Open Sans"/>
@@ -12824,7 +13183,7 @@
             <a:r>
               <a:rPr lang="en-US" sz="1700">
                 <a:solidFill>
-                  <a:srgbClr val="49495A"/>
+                  <a:srgbClr val="C4B8F5"/>
                 </a:solidFill>
                 <a:latin typeface="Open Sans"/>
                 <a:ea typeface="Open Sans"/>
@@ -12853,7 +13212,7 @@
             </a:avLst>
           </a:prstGeom>
           <a:solidFill>
-            <a:srgbClr val="EAE8F3"/>
+            <a:srgbClr val="1A1A2E"/>
           </a:solidFill>
           <a:ln/>
         </p:spPr>
@@ -12875,7 +13234,7 @@
             </a:avLst>
           </a:prstGeom>
           <a:solidFill>
-            <a:srgbClr val="EAE8F3"/>
+            <a:srgbClr val="1A1A2E"/>
           </a:solidFill>
           <a:ln/>
         </p:spPr>
@@ -12939,7 +13298,7 @@
             <a:r>
               <a:rPr lang="en-US" sz="2150">
                 <a:solidFill>
-                  <a:srgbClr val="49495A"/>
+                  <a:srgbClr val="C4B8F5"/>
                 </a:solidFill>
                 <a:latin typeface="Libre Baskerville"/>
                 <a:ea typeface="Libre Baskerville"/>
@@ -12982,7 +13341,7 @@
             <a:r>
               <a:rPr lang="en-US" sz="1700">
                 <a:solidFill>
-                  <a:srgbClr val="49495A"/>
+                  <a:srgbClr val="C4B8F5"/>
                 </a:solidFill>
                 <a:latin typeface="Open Sans"/>
                 <a:ea typeface="Open Sans"/>
@@ -12993,7 +13352,7 @@
             <a:r>
               <a:rPr lang="en-US" sz="1700" b="1">
                 <a:solidFill>
-                  <a:srgbClr val="49495A"/>
+                  <a:srgbClr val="C4B8F5"/>
                 </a:solidFill>
                 <a:latin typeface="Open Sans"/>
                 <a:ea typeface="Open Sans"/>
@@ -13004,7 +13363,7 @@
             <a:r>
               <a:rPr lang="en-US" sz="1700">
                 <a:solidFill>
-                  <a:srgbClr val="49495A"/>
+                  <a:srgbClr val="C4B8F5"/>
                 </a:solidFill>
                 <a:latin typeface="Open Sans"/>
                 <a:ea typeface="Open Sans"/>
@@ -13033,7 +13392,7 @@
             </a:avLst>
           </a:prstGeom>
           <a:solidFill>
-            <a:srgbClr val="B6D6FC"/>
+            <a:srgbClr val="2E3E5C"/>
           </a:solidFill>
           <a:ln/>
         </p:spPr>
@@ -13091,7 +13450,7 @@
             <a:r>
               <a:rPr lang="en-US" sz="1550" b="1">
                 <a:solidFill>
-                  <a:srgbClr val="000000"/>
+                  <a:srgbClr val="F2EEFF"/>
                 </a:solidFill>
                 <a:latin typeface="Open Sans"/>
                 <a:ea typeface="Open Sans"/>
@@ -13102,7 +13461,7 @@
             <a:r>
               <a:rPr lang="en-US" sz="1550">
                 <a:solidFill>
-                  <a:srgbClr val="000000"/>
+                  <a:srgbClr val="F2EEFF"/>
                 </a:solidFill>
                 <a:latin typeface="Open Sans"/>
                 <a:ea typeface="Open Sans"/>
@@ -13113,7 +13472,7 @@
             <a:r>
               <a:rPr lang="en-US" sz="1550" b="1">
                 <a:solidFill>
-                  <a:srgbClr val="000000"/>
+                  <a:srgbClr val="F2EEFF"/>
                 </a:solidFill>
                 <a:latin typeface="Open Sans"/>
                 <a:ea typeface="Open Sans"/>
@@ -13124,7 +13483,7 @@
             <a:r>
               <a:rPr lang="en-US" sz="1550">
                 <a:solidFill>
-                  <a:srgbClr val="000000"/>
+                  <a:srgbClr val="F2EEFF"/>
                 </a:solidFill>
                 <a:latin typeface="Open Sans"/>
                 <a:ea typeface="Open Sans"/>
@@ -13151,7 +13510,7 @@
             <a:avLst/>
           </a:prstGeom>
           <a:solidFill>
-            <a:schemeClr val="bg1"/>
+            <a:srgbClr val="14142E"/>
           </a:solidFill>
           <a:ln w="12700" cap="flat" cmpd="sng" algn="ctr">
             <a:noFill/>
@@ -13256,7 +13615,7 @@
             <a:r>
               <a:rPr lang="en-US" sz="4200" b="1">
                 <a:solidFill>
-                  <a:srgbClr val="403CCF"/>
+                  <a:srgbClr val="9A93F5"/>
                 </a:solidFill>
                 <a:latin typeface="Libre Baskerville"/>
                 <a:ea typeface="Libre Baskerville"/>
@@ -13285,7 +13644,7 @@
             </a:avLst>
           </a:prstGeom>
           <a:solidFill>
-            <a:srgbClr val="E7E0FF"/>
+            <a:srgbClr val="23213C"/>
           </a:solidFill>
           <a:ln/>
         </p:spPr>
@@ -13321,7 +13680,7 @@
             <a:r>
               <a:rPr lang="en-US" sz="2400" b="1">
                 <a:solidFill>
-                  <a:srgbClr val="000000"/>
+                  <a:srgbClr val="F2EEFF"/>
                 </a:solidFill>
                 <a:latin typeface="Libre Baskerville"/>
                 <a:ea typeface="Libre Baskerville"/>
@@ -13364,7 +13723,7 @@
             <a:r>
               <a:rPr lang="en-US" sz="1800" b="1">
                 <a:solidFill>
-                  <a:srgbClr val="49495A"/>
+                  <a:srgbClr val="C4B8F5"/>
                 </a:solidFill>
                 <a:latin typeface="Open Sans"/>
                 <a:ea typeface="Open Sans"/>
@@ -13375,7 +13734,7 @@
             <a:r>
               <a:rPr lang="en-US" sz="1800">
                 <a:solidFill>
-                  <a:srgbClr val="49495A"/>
+                  <a:srgbClr val="C4B8F5"/>
                 </a:solidFill>
                 <a:latin typeface="Open Sans"/>
                 <a:ea typeface="Open Sans"/>
@@ -13418,7 +13777,7 @@
             <a:r>
               <a:rPr lang="en-US" sz="2400" b="1">
                 <a:solidFill>
-                  <a:srgbClr val="000000"/>
+                  <a:srgbClr val="F2EEFF"/>
                 </a:solidFill>
                 <a:latin typeface="Libre Baskerville"/>
                 <a:ea typeface="Libre Baskerville"/>
@@ -13462,7 +13821,7 @@
             <a:r>
               <a:rPr lang="en-US" sz="2000" i="1">
                 <a:solidFill>
-                  <a:srgbClr val="49495A"/>
+                  <a:srgbClr val="C4B8F5"/>
                 </a:solidFill>
                 <a:latin typeface="Open Sans"/>
                 <a:ea typeface="Open Sans"/>
@@ -13484,7 +13843,7 @@
             <a:r>
               <a:rPr lang="en-US" sz="2000" i="1">
                 <a:solidFill>
-                  <a:srgbClr val="49495A"/>
+                  <a:srgbClr val="C4B8F5"/>
                 </a:solidFill>
                 <a:latin typeface="Open Sans"/>
                 <a:ea typeface="Open Sans"/>
@@ -13506,7 +13865,7 @@
             <a:r>
               <a:rPr lang="en-US" sz="2000" i="1">
                 <a:solidFill>
-                  <a:srgbClr val="49495A"/>
+                  <a:srgbClr val="C4B8F5"/>
                 </a:solidFill>
                 <a:latin typeface="Open Sans"/>
                 <a:ea typeface="Open Sans"/>
@@ -13528,7 +13887,7 @@
             <a:r>
               <a:rPr lang="en-US" sz="2000" i="1">
                 <a:solidFill>
-                  <a:srgbClr val="49495A"/>
+                  <a:srgbClr val="C4B8F5"/>
                 </a:solidFill>
                 <a:latin typeface="Open Sans"/>
                 <a:ea typeface="Open Sans"/>
@@ -13539,7 +13898,7 @@
             <a:r>
               <a:rPr lang="en-US" sz="2000" i="1">
                 <a:solidFill>
-                  <a:srgbClr val="49495A"/>
+                  <a:srgbClr val="C4B8F5"/>
                 </a:solidFill>
                 <a:latin typeface="Open Sans"/>
                 <a:ea typeface="Open Sans"/>
@@ -13550,7 +13909,7 @@
             <a:r>
               <a:rPr lang="en-US" sz="2000" i="1">
                 <a:solidFill>
-                  <a:srgbClr val="49495A"/>
+                  <a:srgbClr val="C4B8F5"/>
                 </a:solidFill>
                 <a:latin typeface="Open Sans"/>
                 <a:ea typeface="Open Sans"/>
@@ -13593,7 +13952,7 @@
             <a:r>
               <a:rPr lang="en-US" sz="2800" b="1" i="1">
                 <a:solidFill>
-                  <a:srgbClr val="403CCF"/>
+                  <a:srgbClr val="9A93F5"/>
                 </a:solidFill>
                 <a:latin typeface="Libre Baskerville"/>
                 <a:ea typeface="Libre Baskerville"/>
@@ -13604,7 +13963,7 @@
             <a:r>
               <a:rPr lang="en-US" sz="2800" b="1" i="1">
                 <a:solidFill>
-                  <a:srgbClr val="5955EB"/>
+                  <a:srgbClr val="ADA8F9"/>
                 </a:solidFill>
                 <a:latin typeface="Libre Baskerville"/>
                 <a:ea typeface="Libre Baskerville"/>
@@ -13647,7 +14006,7 @@
             <a:r>
               <a:rPr lang="en-US" sz="1800">
                 <a:solidFill>
-                  <a:srgbClr val="49495A"/>
+                  <a:srgbClr val="C4B8F5"/>
                 </a:solidFill>
                 <a:latin typeface="Open Sans"/>
                 <a:ea typeface="Open Sans"/>
@@ -13718,7 +14077,7 @@
             <a:r>
               <a:rPr lang="en-US" sz="2000" b="1">
                 <a:solidFill>
-                  <a:srgbClr val="49495A"/>
+                  <a:srgbClr val="C4B8F5"/>
                 </a:solidFill>
                 <a:latin typeface="Libre Baskerville"/>
                 <a:ea typeface="Libre Baskerville"/>
@@ -13761,7 +14120,7 @@
             <a:r>
               <a:rPr lang="en-US" sz="1600">
                 <a:solidFill>
-                  <a:srgbClr val="49495A"/>
+                  <a:srgbClr val="C4B8F5"/>
                 </a:solidFill>
                 <a:latin typeface="Open Sans"/>
                 <a:ea typeface="Open Sans"/>
@@ -13832,7 +14191,7 @@
             <a:r>
               <a:rPr lang="en-US" sz="2000" b="1">
                 <a:solidFill>
-                  <a:srgbClr val="49495A"/>
+                  <a:srgbClr val="C4B8F5"/>
                 </a:solidFill>
                 <a:latin typeface="Libre Baskerville"/>
                 <a:ea typeface="Libre Baskerville"/>
@@ -13875,7 +14234,7 @@
             <a:r>
               <a:rPr lang="en-US" sz="1600">
                 <a:solidFill>
-                  <a:srgbClr val="49495A"/>
+                  <a:srgbClr val="C4B8F5"/>
                 </a:solidFill>
                 <a:latin typeface="Open Sans"/>
                 <a:ea typeface="Open Sans"/>
@@ -13946,7 +14305,7 @@
             <a:r>
               <a:rPr lang="en-US" sz="2000" b="1">
                 <a:solidFill>
-                  <a:srgbClr val="49495A"/>
+                  <a:srgbClr val="C4B8F5"/>
                 </a:solidFill>
                 <a:latin typeface="Libre Baskerville"/>
                 <a:ea typeface="Libre Baskerville"/>
@@ -13989,7 +14348,7 @@
             <a:r>
               <a:rPr lang="en-US" sz="1600">
                 <a:solidFill>
-                  <a:srgbClr val="49495A"/>
+                  <a:srgbClr val="C4B8F5"/>
                 </a:solidFill>
                 <a:latin typeface="Open Sans"/>
                 <a:ea typeface="Open Sans"/>
@@ -14060,7 +14419,7 @@
             <a:r>
               <a:rPr lang="en-US" sz="2000" b="1">
                 <a:solidFill>
-                  <a:srgbClr val="49495A"/>
+                  <a:srgbClr val="C4B8F5"/>
                 </a:solidFill>
                 <a:latin typeface="Libre Baskerville"/>
                 <a:ea typeface="Libre Baskerville"/>
@@ -14103,7 +14462,7 @@
             <a:r>
               <a:rPr lang="en-US" sz="1600">
                 <a:solidFill>
-                  <a:srgbClr val="49495A"/>
+                  <a:srgbClr val="C4B8F5"/>
                 </a:solidFill>
                 <a:latin typeface="Open Sans"/>
                 <a:ea typeface="Open Sans"/>
@@ -14174,7 +14533,7 @@
             <a:r>
               <a:rPr lang="en-US" sz="2000" b="1">
                 <a:solidFill>
-                  <a:srgbClr val="49495A"/>
+                  <a:srgbClr val="C4B8F5"/>
                 </a:solidFill>
                 <a:latin typeface="Libre Baskerville"/>
                 <a:ea typeface="Libre Baskerville"/>
@@ -14217,7 +14576,7 @@
             <a:r>
               <a:rPr lang="en-US" sz="1600">
                 <a:solidFill>
-                  <a:srgbClr val="49495A"/>
+                  <a:srgbClr val="C4B8F5"/>
                 </a:solidFill>
                 <a:latin typeface="Open Sans"/>
                 <a:ea typeface="Open Sans"/>
@@ -14260,7 +14619,7 @@
             <a:r>
               <a:rPr lang="en-US" sz="1600">
                 <a:solidFill>
-                  <a:srgbClr val="49495A"/>
+                  <a:srgbClr val="C4B8F5"/>
                 </a:solidFill>
                 <a:latin typeface="Open Sans"/>
                 <a:ea typeface="Open Sans"/>
@@ -14287,7 +14646,7 @@
             <a:avLst/>
           </a:prstGeom>
           <a:solidFill>
-            <a:srgbClr val="403CCF"/>
+            <a:srgbClr val="5A52DC"/>
           </a:solidFill>
           <a:ln/>
         </p:spPr>
@@ -14307,7 +14666,7 @@
             <a:avLst/>
           </a:prstGeom>
           <a:solidFill>
-            <a:schemeClr val="bg1"/>
+            <a:srgbClr val="14142E"/>
           </a:solidFill>
           <a:ln w="12700" cap="flat" cmpd="sng" algn="ctr">
             <a:noFill/>

</xml_diff>